<commit_message>
docs(presentation): rebuild the demo slide around live 2D pose
The slide now carries a screenshot of the running application on the rig,
both camera views showing their own pose overlay computed on the GPU from
the played frames, rather than a recorded still that only implied it.

Co-Authored-By: Claude Opus 5 <noreply@anthropic.com>
</commit_message>
<xml_diff>
--- a/docs/presentation/reachAQ-overview.pptx
+++ b/docs/presentation/reachAQ-overview.pptx
@@ -735,7 +735,7 @@
           </a:p>
           <a:p>
             <a:r>
-              <a:t>2. Show the live camera panels with the pose overlay. Real inference, on played frames.</a:t>
+              <a:t>2. Show the live camera panels. Each view carries its own 2D pose overlay, computed on the GPU from the played frames. This is real inference running now, not a replayed result.</a:t>
             </a:r>
           </a:p>
           <a:p>
@@ -5269,8 +5269,8 @@
         </p:blipFill>
         <p:spPr>
           <a:xfrm>
-            <a:off x="3710555" y="1645920"/>
-            <a:ext cx="4740409" cy="1828800"/>
+            <a:off x="4184596" y="1627632"/>
+            <a:ext cx="3792327" cy="1463040"/>
           </a:xfrm>
           <a:prstGeom prst="rect">
             <a:avLst/>
@@ -5279,7 +5279,7 @@
       </p:pic>
       <p:pic>
         <p:nvPicPr>
-          <p:cNvPr id="5" name="Picture 4" descr="demo_frames.png"/>
+          <p:cNvPr id="5" name="Picture 4" descr="live_overlay.png"/>
           <p:cNvPicPr>
             <a:picLocks noChangeAspect="1"/>
           </p:cNvPicPr>
@@ -5293,14 +5293,48 @@
         </p:blipFill>
         <p:spPr>
           <a:xfrm>
-            <a:off x="3520440" y="3838954"/>
-            <a:ext cx="5120640" cy="2563371"/>
+            <a:off x="2568633" y="3154680"/>
+            <a:ext cx="7024254" cy="2743200"/>
           </a:xfrm>
           <a:prstGeom prst="rect">
             <a:avLst/>
           </a:prstGeom>
         </p:spPr>
       </p:pic>
+      <p:sp>
+        <p:nvSpPr>
+          <p:cNvPr id="6" name="TextBox 5"/>
+          <p:cNvSpPr txBox="1"/>
+          <p:nvPr/>
+        </p:nvSpPr>
+        <p:spPr>
+          <a:xfrm>
+            <a:off x="685800" y="6035040"/>
+            <a:ext cx="10789920" cy="365760"/>
+          </a:xfrm>
+          <a:prstGeom prst="rect">
+            <a:avLst/>
+          </a:prstGeom>
+          <a:noFill/>
+        </p:spPr>
+        <p:txBody>
+          <a:bodyPr wrap="square">
+            <a:spAutoFit/>
+          </a:bodyPr>
+          <a:lstStyle/>
+          <a:p>
+            <a:pPr algn="l"/>
+            <a:r>
+              <a:rPr sz="1200" b="0" i="1">
+                <a:solidFill>
+                  <a:srgbClr val="7A7F87"/>
+                </a:solidFill>
+              </a:rPr>
+              <a:t>Live 2D pose, per view, computed on the GPU from the played frames — captured from the running application on the rig.</a:t>
+            </a:r>
+          </a:p>
+        </p:txBody>
+      </p:sp>
     </p:spTree>
   </p:cSld>
   <p:clrMapOvr>

</xml_diff>

<commit_message>
docs(presentation): rebuild the deck file at its real path
Co-Authored-By: Claude Opus 5 <noreply@anthropic.com>
</commit_message>
<xml_diff>
--- a/docs/presentation/reachAQ-overview.pptx
+++ b/docs/presentation/reachAQ-overview.pptx
@@ -17,8 +17,6 @@
     <p:sldId id="265" r:id="rId17"/>
     <p:sldId id="266" r:id="rId18"/>
     <p:sldId id="267" r:id="rId19"/>
-    <p:sldId id="268" r:id="rId20"/>
-    <p:sldId id="269" r:id="rId21"/>
   </p:sldIdLst>
   <p:sldSz cx="12191695" cy="6858000" type="screen4x3"/>
   <p:notesSz cx="6858000" cy="9144000"/>
@@ -585,7 +583,7 @@
           <a:lstStyle/>
           <a:p>
             <a:r>
-              <a:t>Four sync modes: auto, backplane, external, independent. Compatible PXI cards share PXI_CLK10, a backplane start trigger and a routed master sample clock. Devices resolve by product and serial, so a changed NI-DAQmx alias never silently rebinds to the wrong card. Tone confirmation cross-checks commanded tones against the pulses actually observed.</a:t>
+              <a:t>The pinning behaviour is the part worth dwelling on. It is what stops an edit to a shared phase from quietly changing an experiment that was already validated.</a:t>
             </a:r>
           </a:p>
         </p:txBody>
@@ -655,146 +653,6 @@
           <a:lstStyle/>
           <a:p>
             <a:r>
-              <a:t>The point for a new user is that this replaces post-hoc plotting. A decimated FSR trace is useless for behavioural analysis, so samples are forwarded unthrottled and an armed session gains roughly 166 rows a second. Worth flagging out loud: there is no microphone channel in the system today.</a:t>
-            </a:r>
-          </a:p>
-        </p:txBody>
-      </p:sp>
-      <p:sp>
-        <p:nvSpPr>
-          <p:cNvPr id="4" name="Slide Number Placeholder 3"/>
-          <p:cNvSpPr>
-            <a:spLocks noGrp="1"/>
-          </p:cNvSpPr>
-          <p:nvPr>
-            <p:ph type="sldNum" idx="5" sz="quarter"/>
-          </p:nvPr>
-        </p:nvSpPr>
-        <p:spPr/>
-      </p:sp>
-    </p:spTree>
-  </p:cSld>
-  <p:clrMapOvr>
-    <a:masterClrMapping/>
-  </p:clrMapOvr>
-</p:notes>
-</file>
-
-<file path=ppt/notesSlides/notesSlide12.xml><?xml version="1.0" encoding="utf-8"?>
-<p:notes xmlns:a="http://schemas.openxmlformats.org/drawingml/2006/main" xmlns:p="http://schemas.openxmlformats.org/presentationml/2006/main" xmlns:r="http://schemas.openxmlformats.org/officeDocument/2006/relationships">
-  <p:cSld>
-    <p:spTree>
-      <p:nvGrpSpPr>
-        <p:cNvPr id="1" name=""/>
-        <p:cNvGrpSpPr/>
-        <p:nvPr/>
-      </p:nvGrpSpPr>
-      <p:grpSpPr>
-        <a:xfrm>
-          <a:off x="0" y="0"/>
-          <a:ext cx="0" cy="0"/>
-          <a:chOff x="0" y="0"/>
-          <a:chExt cx="0" cy="0"/>
-        </a:xfrm>
-      </p:grpSpPr>
-      <p:sp>
-        <p:nvSpPr>
-          <p:cNvPr id="2" name="Slide Image Placeholder 1"/>
-          <p:cNvSpPr>
-            <a:spLocks noGrp="1"/>
-          </p:cNvSpPr>
-          <p:nvPr>
-            <p:ph type="sldImg" idx="2"/>
-          </p:nvPr>
-        </p:nvSpPr>
-        <p:spPr/>
-      </p:sp>
-      <p:sp>
-        <p:nvSpPr>
-          <p:cNvPr id="3" name="Notes Placeholder 2"/>
-          <p:cNvSpPr>
-            <a:spLocks noGrp="1"/>
-          </p:cNvSpPr>
-          <p:nvPr>
-            <p:ph type="body" idx="3" sz="quarter"/>
-          </p:nvPr>
-        </p:nvSpPr>
-        <p:spPr/>
-        <p:txBody>
-          <a:bodyPr/>
-          <a:lstStyle/>
-          <a:p>
-            <a:r>
-              <a:t>The pinning behaviour is the part worth dwelling on. It is what stops an edit to a shared phase from quietly changing an experiment that was already validated.</a:t>
-            </a:r>
-          </a:p>
-        </p:txBody>
-      </p:sp>
-      <p:sp>
-        <p:nvSpPr>
-          <p:cNvPr id="4" name="Slide Number Placeholder 3"/>
-          <p:cNvSpPr>
-            <a:spLocks noGrp="1"/>
-          </p:cNvSpPr>
-          <p:nvPr>
-            <p:ph type="sldNum" idx="5" sz="quarter"/>
-          </p:nvPr>
-        </p:nvSpPr>
-        <p:spPr/>
-      </p:sp>
-    </p:spTree>
-  </p:cSld>
-  <p:clrMapOvr>
-    <a:masterClrMapping/>
-  </p:clrMapOvr>
-</p:notes>
-</file>
-
-<file path=ppt/notesSlides/notesSlide13.xml><?xml version="1.0" encoding="utf-8"?>
-<p:notes xmlns:a="http://schemas.openxmlformats.org/drawingml/2006/main" xmlns:p="http://schemas.openxmlformats.org/presentationml/2006/main" xmlns:r="http://schemas.openxmlformats.org/officeDocument/2006/relationships">
-  <p:cSld>
-    <p:spTree>
-      <p:nvGrpSpPr>
-        <p:cNvPr id="1" name=""/>
-        <p:cNvGrpSpPr/>
-        <p:nvPr/>
-      </p:nvGrpSpPr>
-      <p:grpSpPr>
-        <a:xfrm>
-          <a:off x="0" y="0"/>
-          <a:ext cx="0" cy="0"/>
-          <a:chOff x="0" y="0"/>
-          <a:chExt cx="0" cy="0"/>
-        </a:xfrm>
-      </p:grpSpPr>
-      <p:sp>
-        <p:nvSpPr>
-          <p:cNvPr id="2" name="Slide Image Placeholder 1"/>
-          <p:cNvSpPr>
-            <a:spLocks noGrp="1"/>
-          </p:cNvSpPr>
-          <p:nvPr>
-            <p:ph type="sldImg" idx="2"/>
-          </p:nvPr>
-        </p:nvSpPr>
-        <p:spPr/>
-      </p:sp>
-      <p:sp>
-        <p:nvSpPr>
-          <p:cNvPr id="3" name="Notes Placeholder 2"/>
-          <p:cNvSpPr>
-            <a:spLocks noGrp="1"/>
-          </p:cNvSpPr>
-          <p:nvPr>
-            <p:ph type="body" idx="3" sz="quarter"/>
-          </p:nvPr>
-        </p:nvSpPr>
-        <p:spPr/>
-        <p:txBody>
-          <a:bodyPr/>
-          <a:lstStyle/>
-          <a:p>
-            <a:r>
               <a:t>Run order — launch with --demo or toggle Tools &gt; Demo Mode while idle; show both camera panels carrying their own overlay; show the NI-DAQ signal stream; drive the pellet device by hand; open the protocol editor and the experiment sidebar; start a recording and let trials run; stop and show the session directory with its DEMO marker. Point at the red banner — it is there so nobody mistakes a demo session for data.</a:t>
             </a:r>
           </a:p>
@@ -935,7 +793,7 @@
           <a:lstStyle/>
           <a:p>
             <a:r>
-              <a:t>This slide exists so the numbers later have something to be measured against. Do not let 5 ms drift into sounding like an average — it is the tail figure the loop is designed to hold.</a:t>
+              <a:t>This slide exists so the later numbers have something to be measured against. The user-facing consequence is the line that matters: before, pose was a recording product; now it is a control input. Keep 5 ms described as a budget and a tail figure, never an average.</a:t>
             </a:r>
           </a:p>
         </p:txBody>
@@ -1005,7 +863,7 @@
           <a:lstStyle/>
           <a:p>
             <a:r>
-              <a:t>This is the organising idea of the whole section. The payoff for a user is that there are now two closed loops available — the fast ROI reflex, and machine vision on the pose stream — rather than one compromise between them.</a:t>
+              <a:t>This is the words-before-the-graph slide. Technical detail for the members who want it: partial batch and the lean predict path need the PyTorch engine, because the TensorFlow graph fixes its batch size; the ROI crop from 256 to 128 px is opt-in and worth about 2.6x on the forward pass; the decode rewrite and the freshness drain are always on and model-independent. The freshness drain alone took end-to-end from 17.6 to 13.9 ms and cut frames the loop could not hand over from 35.2% to 0.7%.</a:t>
             </a:r>
           </a:p>
         </p:txBody>
@@ -1075,7 +933,7 @@
           <a:lstStyle/>
           <a:p>
             <a:r>
-              <a:t>Adopted: SCHED_FIFO plus the performance CPU governor. Both a PREEMPT_RT kernel and core pinning were measured and declined — stock Linux already preempts SCHED_OTHER for SCHED_FIFO, and the result leaves roughly 32x headroom under a load harsher than real acquisition.</a:t>
+              <a:t>Left: under a 16-process load the reflex loop's worst case went from 6.05 ms, which breaks the budget, to 0.155 ms with zero missed deadlines and the full 900 Hz cadence restored. No PREEMPT_RT kernel and no core pinning — both measured, both declined. Right: the three pose-stream changes, each shown against its own before. Units differ between rows, which is why they are labelled per row rather than sharing an axis. All figures are rig measurements on this hardware, not claims about other cards.</a:t>
             </a:r>
           </a:p>
         </p:txBody>
@@ -1145,7 +1003,7 @@
           <a:lstStyle/>
           <a:p>
             <a:r>
-              <a:t>Partial batch — running the 2 real frames instead of a padded 6 — took 54.8 to 25.3 ms, and needs the PyTorch engine because the TensorFlow graph fixes its batch size. The decode rewrite, argmax instead of sort with cached column indices and numpy instead of pandas, is always on and model-independent. Also gated: an ROI crop from 256 to 128 px, worth about 2.6x on the forward pass, and a lean predict path worth about 1.2 ms per call. CUDA-graph capture, 7.4 to 3.6 ms, is YOLO-backend only. The engine migration to PyTorch is roughly neutral like-for-like — its value is unlocking newer GPUs, dynamic batching and everything above it.</a:t>
+              <a:t>The honest framing is a menu, not a winner. A user optimising for a tight closed loop picks differently from one optimising for keypoint accuracy in later analysis. The per-backbone threshold matters: a cspnext_s never scores above 0.33, so a single global threshold would hold the reach flag permanently false.</a:t>
             </a:r>
           </a:p>
         </p:txBody>
@@ -1215,7 +1073,7 @@
           <a:lstStyle/>
           <a:p>
             <a:r>
-              <a:t>Worth pairing with the Tier 1 slide — the governor is one of the two always-on system settings, alongside real-time scheduling.</a:t>
+              <a:t>If asked about flags: a default rig gets the always-on wins, the decode rewrite and the freshness drain, plus the Tier 1 scheduling. The partial batch and lean predict path need the PyTorch backend selected, and the ROI crop is opt-in.</a:t>
             </a:r>
           </a:p>
         </p:txBody>
@@ -1285,7 +1143,7 @@
           <a:lstStyle/>
           <a:p>
             <a:r>
-              <a:t>This is the correctness property, not a speedup, and it is what makes "pose runs below camera rate" an accepted design point rather than a hazard. Worth saying out loud for an audience that will otherwise assume a slow model drops data.</a:t>
+              <a:t>Four sync modes: auto, backplane, external, independent. Compatible PXI cards share PXI_CLK10, a backplane start trigger and a routed master sample clock. Devices resolve by product and serial, so a changed NI-DAQmx alias never silently rebinds to the wrong card. Tone confirmation cross-checks commanded tones against the pulses actually observed.</a:t>
             </a:r>
           </a:p>
         </p:txBody>
@@ -1355,7 +1213,7 @@
           <a:lstStyle/>
           <a:p>
             <a:r>
-              <a:t>This slide is for the technical audience. If asked about INT8 — it could pay on Turing's DP4A, the route tried produced a broken engine, and the correct route is identified but not done. Figures throughout are rig measurements on this hardware; they are not claims about other cards.</a:t>
+              <a:t>The point for a new user is that this replaces post-hoc plotting. A decimated FSR trace is useless for behavioural analysis, so samples are forwarded unthrottled and an armed session gains roughly 166 rows a second. Worth flagging out loud: there is no microphone channel in the system today.</a:t>
             </a:r>
           </a:p>
         </p:txBody>
@@ -4517,7 +4375,7 @@
                 </a:solidFill>
                 <a:latin typeface="Segoe UI"/>
               </a:rPr>
-              <a:t>Benchmarked, and not taken</a:t>
+              <a:t>Signals you can watch while the session runs</a:t>
             </a:r>
           </a:p>
         </p:txBody>
@@ -4554,7 +4412,7 @@
                 </a:solidFill>
                 <a:latin typeface="Segoe UI"/>
               </a:rPr>
-              <a:t>fp16 / mixed precision — 3 to 4x slower on this card. The T1000 has no tensor cores, so the default stays fp32</a:t>
+              <a:t>Tones 1, 2 and 3 as logic traces, with the commanded onset checked against the pulse the DAQ actually saw</a:t>
             </a:r>
           </a:p>
           <a:p>
@@ -4570,7 +4428,7 @@
                 </a:solidFill>
                 <a:latin typeface="Segoe UI"/>
               </a:rPr>
-              <a:t>torch.compile — about 0.99x, and slower on the larger model</a:t>
+              <a:t>Pellet FSR pressure — two sensors at about 83 Hz each, from firmware 2.1.0, on their own stream rather than mixed into the device log</a:t>
             </a:r>
           </a:p>
           <a:p>
@@ -4586,7 +4444,7 @@
                 </a:solidFill>
                 <a:latin typeface="Segoe UI"/>
               </a:rPr>
-              <a:t>ONNX Runtime on CUDA — matches PyTorch at 0.99x</a:t>
+              <a:t>Laser analog command alongside the diode readback, so what was asked for and what came out are on the same axis</a:t>
             </a:r>
           </a:p>
           <a:p>
@@ -4602,7 +4460,7 @@
                 </a:solidFill>
                 <a:latin typeface="Segoe UI"/>
               </a:rPr>
-              <a:t>TensorRT — a real 1.30 to 1.36x, the only external-runtime win, rejected on cost: per-model export, per-card engine builds, 6.4 GB of libraries, a second inference path and a CUDA-version reconciliation</a:t>
+              <a:t>Camera frame pulses and the barcode line, which are what tie video to samples</a:t>
             </a:r>
           </a:p>
           <a:p>
@@ -4618,7 +4476,7 @@
                 </a:solidFill>
                 <a:latin typeface="Segoe UI"/>
               </a:rPr>
-              <a:t>The honest summary: the speed came from removing our own overhead and picking the right architecture, not from a magic runtime</a:t>
+              <a:t>Closed-loop state: what the pose gate answered, when the cue fired, and whether the trial was cancelled</a:t>
             </a:r>
           </a:p>
         </p:txBody>
@@ -4696,7 +4554,7 @@
                 </a:solidFill>
                 <a:latin typeface="Segoe UI"/>
               </a:rPr>
-              <a:t>Every acceleration knob was measured on the rig. Several gave nothing here.</a:t>
+              <a:t>Everything is acquired continuously at 10 kHz and recorded unfiltered. The plot selection only changes what is drawn.</a:t>
             </a:r>
           </a:p>
         </p:txBody>
@@ -4816,14 +4674,131 @@
                 </a:solidFill>
                 <a:latin typeface="Segoe UI"/>
               </a:rPr>
-              <a:t>Everything lands on one timebase</a:t>
-            </a:r>
-          </a:p>
-        </p:txBody>
-      </p:sp>
-      <p:sp>
-        <p:nvSpPr>
-          <p:cNvPr id="3" name="Rectangle 2"/>
+              <a:t>Experiments are composed, not copied</a:t>
+            </a:r>
+          </a:p>
+        </p:txBody>
+      </p:sp>
+      <p:sp>
+        <p:nvSpPr>
+          <p:cNvPr id="3" name="Content Placeholder 2"/>
+          <p:cNvSpPr>
+            <a:spLocks noGrp="1"/>
+          </p:cNvSpPr>
+          <p:nvPr>
+            <p:ph idx="1"/>
+          </p:nvPr>
+        </p:nvSpPr>
+        <p:spPr>
+          <a:xfrm>
+            <a:off x="658368" y="2057400"/>
+            <a:ext cx="10874959" cy="4023360"/>
+          </a:xfrm>
+        </p:spPr>
+        <p:txBody>
+          <a:bodyPr wrap="square"/>
+          <a:lstStyle/>
+          <a:p>
+            <a:pPr>
+              <a:spcAft>
+                <a:spcPts val="1300"/>
+              </a:spcAft>
+            </a:pPr>
+            <a:r>
+              <a:rPr sz="1500" b="0" i="0">
+                <a:solidFill>
+                  <a:srgbClr val="1E242B"/>
+                </a:solidFill>
+                <a:latin typeface="Segoe UI"/>
+              </a:rPr>
+              <a:t>A trial set is a reusable group of trials, saved on its own — trial content only, no epochs or blocks</a:t>
+            </a:r>
+          </a:p>
+          <a:p>
+            <a:pPr>
+              <a:spcAft>
+                <a:spcPts val="1300"/>
+              </a:spcAft>
+            </a:pPr>
+            <a:r>
+              <a:rPr sz="1500" b="0" i="0">
+                <a:solidFill>
+                  <a:srgbClr val="1E242B"/>
+                </a:solidFill>
+                <a:latin typeface="Segoe UI"/>
+              </a:rPr>
+              <a:t>An experiment is an ordered list of set appearances; each entry pins the set revision it was built against, can repeat, and can shuffle trial order within an appearance</a:t>
+            </a:r>
+          </a:p>
+          <a:p>
+            <a:pPr>
+              <a:spcAft>
+                <a:spcPts val="1300"/>
+              </a:spcAft>
+            </a:pPr>
+            <a:r>
+              <a:rPr sz="1500" b="0" i="0">
+                <a:solidFill>
+                  <a:srgbClr val="1E242B"/>
+                </a:solidFill>
+                <a:latin typeface="Segoe UI"/>
+              </a:rPr>
+              <a:t>Compiling flattens it into an ordinary protocol document, so the runner, the schedule and session evidence see nothing new</a:t>
+            </a:r>
+          </a:p>
+          <a:p>
+            <a:pPr>
+              <a:spcAft>
+                <a:spcPts val="1300"/>
+              </a:spcAft>
+            </a:pPr>
+            <a:r>
+              <a:rPr sz="1500" b="0" i="0">
+                <a:solidFill>
+                  <a:srgbClr val="1E242B"/>
+                </a:solidFill>
+                <a:latin typeface="Segoe UI"/>
+              </a:rPr>
+              <a:t>Each appearance becomes a named epoch, and the Sources column names the set every value came from</a:t>
+            </a:r>
+          </a:p>
+          <a:p>
+            <a:pPr>
+              <a:spcAft>
+                <a:spcPts val="1300"/>
+              </a:spcAft>
+            </a:pPr>
+            <a:r>
+              <a:rPr sz="1500" b="0" i="0">
+                <a:solidFill>
+                  <a:srgbClr val="1E242B"/>
+                </a:solidFill>
+                <a:latin typeface="Segoe UI"/>
+              </a:rPr>
+              <a:t>Shuffle seeds are stored on the entry, so a compile can always be repeated exactly</a:t>
+            </a:r>
+          </a:p>
+          <a:p>
+            <a:pPr>
+              <a:spcAft>
+                <a:spcPts val="1300"/>
+              </a:spcAft>
+            </a:pPr>
+            <a:r>
+              <a:rPr sz="1500" b="0" i="0">
+                <a:solidFill>
+                  <a:srgbClr val="1E242B"/>
+                </a:solidFill>
+                <a:latin typeface="Segoe UI"/>
+              </a:rPr>
+              <a:t>Editing a set never repins an existing row; a stale pin is visible, and a compile against a changed set is refused rather than silently different</a:t>
+            </a:r>
+          </a:p>
+        </p:txBody>
+      </p:sp>
+      <p:sp>
+        <p:nvSpPr>
+          <p:cNvPr id="4" name="Rectangle 3"/>
           <p:cNvSpPr/>
           <p:nvPr/>
         </p:nvSpPr>
@@ -4867,7 +4842,7 @@
       </p:sp>
       <p:sp>
         <p:nvSpPr>
-          <p:cNvPr id="4" name="TextBox 3"/>
+          <p:cNvPr id="5" name="TextBox 4"/>
           <p:cNvSpPr txBox="1"/>
           <p:nvPr/>
         </p:nvSpPr>
@@ -4894,35 +4869,11 @@
                 </a:solidFill>
                 <a:latin typeface="Segoe UI"/>
               </a:rPr>
-              <a:t>Cameras, tones, pellet events and laser output are not separately timestamped and hoped to agree.</a:t>
-            </a:r>
-          </a:p>
-        </p:txBody>
-      </p:sp>
-      <p:pic>
-        <p:nvPicPr>
-          <p:cNvPr id="5" name="Picture 4" descr="synchronization.png"/>
-          <p:cNvPicPr>
-            <a:picLocks noChangeAspect="1"/>
-          </p:cNvPicPr>
-          <p:nvPr/>
-        </p:nvPicPr>
-        <p:blipFill>
-          <a:blip r:embed="rId2"/>
-          <a:stretch>
-            <a:fillRect/>
-          </a:stretch>
-        </p:blipFill>
-        <p:spPr>
-          <a:xfrm>
-            <a:off x="658368" y="1847088"/>
-            <a:ext cx="10874959" cy="3663144"/>
-          </a:xfrm>
-          <a:prstGeom prst="rect">
-            <a:avLst/>
-          </a:prstGeom>
-        </p:spPr>
-      </p:pic>
+              <a:t>A phase shared by several experiments is written once.</a:t>
+            </a:r>
+          </a:p>
+        </p:txBody>
+      </p:sp>
       <p:sp>
         <p:nvSpPr>
           <p:cNvPr id="6" name="TextBox 5"/>
@@ -4931,8 +4882,8 @@
         </p:nvSpPr>
         <p:spPr>
           <a:xfrm>
-            <a:off x="658368" y="5638248"/>
-            <a:ext cx="10874959" cy="502920"/>
+            <a:off x="658368" y="6382512"/>
+            <a:ext cx="10874959" cy="292608"/>
           </a:xfrm>
           <a:prstGeom prst="rect">
             <a:avLst/>
@@ -4940,41 +4891,6 @@
           <a:noFill/>
         </p:spPr>
         <p:txBody>
-          <a:bodyPr wrap="square">
-            <a:spAutoFit/>
-          </a:bodyPr>
-          <a:lstStyle/>
-          <a:p>
-            <a:pPr algn="ctr"/>
-            <a:r>
-              <a:rPr sz="1150" b="0" i="1">
-                <a:solidFill>
-                  <a:srgbClr val="6B727B"/>
-                </a:solidFill>
-                <a:latin typeface="Segoe UI"/>
-              </a:rPr>
-              <a:t>Camera frame edges are matched to NI-DAQ samples with a signed offset, a resolution, and a confidence — all written into alignment.json.</a:t>
-            </a:r>
-          </a:p>
-        </p:txBody>
-      </p:sp>
-      <p:sp>
-        <p:nvSpPr>
-          <p:cNvPr id="7" name="TextBox 6"/>
-          <p:cNvSpPr txBox="1"/>
-          <p:nvPr/>
-        </p:nvSpPr>
-        <p:spPr>
-          <a:xfrm>
-            <a:off x="658368" y="6382512"/>
-            <a:ext cx="10874959" cy="292608"/>
-          </a:xfrm>
-          <a:prstGeom prst="rect">
-            <a:avLst/>
-          </a:prstGeom>
-          <a:noFill/>
-        </p:spPr>
-        <p:txBody>
           <a:bodyPr wrap="none">
             <a:spAutoFit/>
           </a:bodyPr>
@@ -4994,7 +4910,7 @@
       </p:sp>
       <p:sp>
         <p:nvSpPr>
-          <p:cNvPr id="8" name="TextBox 7"/>
+          <p:cNvPr id="7" name="TextBox 6"/>
           <p:cNvSpPr txBox="1"/>
           <p:nvPr/>
         </p:nvSpPr>
@@ -5073,115 +4989,14 @@
                 </a:solidFill>
                 <a:latin typeface="Segoe UI"/>
               </a:rPr>
-              <a:t>Signals you can watch while the session runs</a:t>
-            </a:r>
-          </a:p>
-        </p:txBody>
-      </p:sp>
-      <p:sp>
-        <p:nvSpPr>
-          <p:cNvPr id="3" name="Content Placeholder 2"/>
-          <p:cNvSpPr>
-            <a:spLocks noGrp="1"/>
-          </p:cNvSpPr>
-          <p:nvPr>
-            <p:ph idx="1"/>
-          </p:nvPr>
-        </p:nvSpPr>
-        <p:spPr>
-          <a:xfrm>
-            <a:off x="658368" y="2057400"/>
-            <a:ext cx="10874959" cy="4023360"/>
-          </a:xfrm>
-        </p:spPr>
-        <p:txBody>
-          <a:bodyPr wrap="square"/>
-          <a:lstStyle/>
-          <a:p>
-            <a:pPr>
-              <a:spcAft>
-                <a:spcPts val="1300"/>
-              </a:spcAft>
-            </a:pPr>
-            <a:r>
-              <a:rPr sz="1500" b="0" i="0">
-                <a:solidFill>
-                  <a:srgbClr val="1E242B"/>
-                </a:solidFill>
-                <a:latin typeface="Segoe UI"/>
-              </a:rPr>
-              <a:t>Tones 1, 2 and 3 as logic traces, with the commanded onset checked against the pulse the DAQ actually saw</a:t>
-            </a:r>
-          </a:p>
-          <a:p>
-            <a:pPr>
-              <a:spcAft>
-                <a:spcPts val="1300"/>
-              </a:spcAft>
-            </a:pPr>
-            <a:r>
-              <a:rPr sz="1500" b="0" i="0">
-                <a:solidFill>
-                  <a:srgbClr val="1E242B"/>
-                </a:solidFill>
-                <a:latin typeface="Segoe UI"/>
-              </a:rPr>
-              <a:t>Pellet FSR pressure — two sensors at about 83 Hz each, from firmware 2.1.0, on their own stream rather than mixed into the device log</a:t>
-            </a:r>
-          </a:p>
-          <a:p>
-            <a:pPr>
-              <a:spcAft>
-                <a:spcPts val="1300"/>
-              </a:spcAft>
-            </a:pPr>
-            <a:r>
-              <a:rPr sz="1500" b="0" i="0">
-                <a:solidFill>
-                  <a:srgbClr val="1E242B"/>
-                </a:solidFill>
-                <a:latin typeface="Segoe UI"/>
-              </a:rPr>
-              <a:t>Laser analog command alongside the diode readback, so what was asked for and what came out are on the same axis</a:t>
-            </a:r>
-          </a:p>
-          <a:p>
-            <a:pPr>
-              <a:spcAft>
-                <a:spcPts val="1300"/>
-              </a:spcAft>
-            </a:pPr>
-            <a:r>
-              <a:rPr sz="1500" b="0" i="0">
-                <a:solidFill>
-                  <a:srgbClr val="1E242B"/>
-                </a:solidFill>
-                <a:latin typeface="Segoe UI"/>
-              </a:rPr>
-              <a:t>Camera frame pulses and the barcode line, which are what tie video to samples</a:t>
-            </a:r>
-          </a:p>
-          <a:p>
-            <a:pPr>
-              <a:spcAft>
-                <a:spcPts val="1300"/>
-              </a:spcAft>
-            </a:pPr>
-            <a:r>
-              <a:rPr sz="1500" b="0" i="0">
-                <a:solidFill>
-                  <a:srgbClr val="1E242B"/>
-                </a:solidFill>
-                <a:latin typeface="Segoe UI"/>
-              </a:rPr>
-              <a:t>Closed-loop state: what the pose gate answered, when the cue fired, and whether the trial was cancelled</a:t>
-            </a:r>
-          </a:p>
-        </p:txBody>
-      </p:sp>
-      <p:sp>
-        <p:nvSpPr>
-          <p:cNvPr id="4" name="Rectangle 3"/>
+              <a:t>Demo — recorded video, everything else live</a:t>
+            </a:r>
+          </a:p>
+        </p:txBody>
+      </p:sp>
+      <p:sp>
+        <p:nvSpPr>
+          <p:cNvPr id="3" name="Rectangle 2"/>
           <p:cNvSpPr/>
           <p:nvPr/>
         </p:nvSpPr>
@@ -5225,519 +5040,6 @@
       </p:sp>
       <p:sp>
         <p:nvSpPr>
-          <p:cNvPr id="5" name="TextBox 4"/>
-          <p:cNvSpPr txBox="1"/>
-          <p:nvPr/>
-        </p:nvSpPr>
-        <p:spPr>
-          <a:xfrm>
-            <a:off x="658368" y="1371600"/>
-            <a:ext cx="10874959" cy="457200"/>
-          </a:xfrm>
-          <a:prstGeom prst="rect">
-            <a:avLst/>
-          </a:prstGeom>
-          <a:noFill/>
-        </p:spPr>
-        <p:txBody>
-          <a:bodyPr wrap="square">
-            <a:spAutoFit/>
-          </a:bodyPr>
-          <a:lstStyle/>
-          <a:p>
-            <a:r>
-              <a:rPr sz="1400" b="0" i="1">
-                <a:solidFill>
-                  <a:srgbClr val="6B727B"/>
-                </a:solidFill>
-                <a:latin typeface="Segoe UI"/>
-              </a:rPr>
-              <a:t>Everything is acquired continuously at 10 kHz and recorded unfiltered. The plot selection only changes what is drawn.</a:t>
-            </a:r>
-          </a:p>
-        </p:txBody>
-      </p:sp>
-      <p:sp>
-        <p:nvSpPr>
-          <p:cNvPr id="6" name="TextBox 5"/>
-          <p:cNvSpPr txBox="1"/>
-          <p:nvPr/>
-        </p:nvSpPr>
-        <p:spPr>
-          <a:xfrm>
-            <a:off x="658368" y="6382512"/>
-            <a:ext cx="10874959" cy="292608"/>
-          </a:xfrm>
-          <a:prstGeom prst="rect">
-            <a:avLst/>
-          </a:prstGeom>
-          <a:noFill/>
-        </p:spPr>
-        <p:txBody>
-          <a:bodyPr wrap="none">
-            <a:spAutoFit/>
-          </a:bodyPr>
-          <a:lstStyle/>
-          <a:p>
-            <a:r>
-              <a:rPr sz="900" b="0" i="0">
-                <a:solidFill>
-                  <a:srgbClr val="6B727B"/>
-                </a:solidFill>
-                <a:latin typeface="Segoe UI"/>
-              </a:rPr>
-              <a:t>reachAQ</a:t>
-            </a:r>
-          </a:p>
-        </p:txBody>
-      </p:sp>
-      <p:sp>
-        <p:nvSpPr>
-          <p:cNvPr id="7" name="TextBox 6"/>
-          <p:cNvSpPr txBox="1"/>
-          <p:nvPr/>
-        </p:nvSpPr>
-        <p:spPr>
-          <a:xfrm>
-            <a:off x="10893247" y="6382512"/>
-            <a:ext cx="640080" cy="292608"/>
-          </a:xfrm>
-          <a:prstGeom prst="rect">
-            <a:avLst/>
-          </a:prstGeom>
-          <a:noFill/>
-        </p:spPr>
-        <p:txBody>
-          <a:bodyPr wrap="none">
-            <a:spAutoFit/>
-          </a:bodyPr>
-          <a:lstStyle/>
-          <a:p>
-            <a:pPr algn="r"/>
-            <a:r>
-              <a:rPr sz="900" b="0" i="0">
-                <a:solidFill>
-                  <a:srgbClr val="6B727B"/>
-                </a:solidFill>
-                <a:latin typeface="Segoe UI"/>
-              </a:rPr>
-              <a:t>12</a:t>
-            </a:r>
-          </a:p>
-        </p:txBody>
-      </p:sp>
-    </p:spTree>
-  </p:cSld>
-  <p:clrMapOvr>
-    <a:masterClrMapping/>
-  </p:clrMapOvr>
-</p:sld>
-</file>
-
-<file path=ppt/slides/slide13.xml><?xml version="1.0" encoding="utf-8"?>
-<p:sld xmlns:a="http://schemas.openxmlformats.org/drawingml/2006/main" xmlns:p="http://schemas.openxmlformats.org/presentationml/2006/main" xmlns:r="http://schemas.openxmlformats.org/officeDocument/2006/relationships">
-  <p:cSld>
-    <p:spTree>
-      <p:nvGrpSpPr>
-        <p:cNvPr id="1" name=""/>
-        <p:cNvGrpSpPr/>
-        <p:nvPr/>
-      </p:nvGrpSpPr>
-      <p:grpSpPr/>
-      <p:sp>
-        <p:nvSpPr>
-          <p:cNvPr id="2" name="Title 1"/>
-          <p:cNvSpPr>
-            <a:spLocks noGrp="1"/>
-          </p:cNvSpPr>
-          <p:nvPr>
-            <p:ph type="title"/>
-          </p:nvPr>
-        </p:nvSpPr>
-        <p:spPr>
-          <a:xfrm>
-            <a:off x="658368" y="457200"/>
-            <a:ext cx="10874959" cy="868680"/>
-          </a:xfrm>
-        </p:spPr>
-        <p:txBody>
-          <a:bodyPr wrap="square"/>
-          <a:lstStyle/>
-          <a:p>
-            <a:pPr algn="l"/>
-            <a:r>
-              <a:rPr sz="3000" b="1" i="0">
-                <a:solidFill>
-                  <a:srgbClr val="1E242B"/>
-                </a:solidFill>
-                <a:latin typeface="Segoe UI"/>
-              </a:rPr>
-              <a:t>Experiments are composed, not copied</a:t>
-            </a:r>
-          </a:p>
-        </p:txBody>
-      </p:sp>
-      <p:sp>
-        <p:nvSpPr>
-          <p:cNvPr id="3" name="Content Placeholder 2"/>
-          <p:cNvSpPr>
-            <a:spLocks noGrp="1"/>
-          </p:cNvSpPr>
-          <p:nvPr>
-            <p:ph idx="1"/>
-          </p:nvPr>
-        </p:nvSpPr>
-        <p:spPr>
-          <a:xfrm>
-            <a:off x="658368" y="2057400"/>
-            <a:ext cx="10874959" cy="4023360"/>
-          </a:xfrm>
-        </p:spPr>
-        <p:txBody>
-          <a:bodyPr wrap="square"/>
-          <a:lstStyle/>
-          <a:p>
-            <a:pPr>
-              <a:spcAft>
-                <a:spcPts val="1300"/>
-              </a:spcAft>
-            </a:pPr>
-            <a:r>
-              <a:rPr sz="1500" b="0" i="0">
-                <a:solidFill>
-                  <a:srgbClr val="1E242B"/>
-                </a:solidFill>
-                <a:latin typeface="Segoe UI"/>
-              </a:rPr>
-              <a:t>A trial set is a reusable group of trials, saved on its own — trial content only, no epochs or blocks</a:t>
-            </a:r>
-          </a:p>
-          <a:p>
-            <a:pPr>
-              <a:spcAft>
-                <a:spcPts val="1300"/>
-              </a:spcAft>
-            </a:pPr>
-            <a:r>
-              <a:rPr sz="1500" b="0" i="0">
-                <a:solidFill>
-                  <a:srgbClr val="1E242B"/>
-                </a:solidFill>
-                <a:latin typeface="Segoe UI"/>
-              </a:rPr>
-              <a:t>An experiment is an ordered list of set appearances; each entry pins the set revision it was built against, can repeat, and can shuffle trial order within an appearance</a:t>
-            </a:r>
-          </a:p>
-          <a:p>
-            <a:pPr>
-              <a:spcAft>
-                <a:spcPts val="1300"/>
-              </a:spcAft>
-            </a:pPr>
-            <a:r>
-              <a:rPr sz="1500" b="0" i="0">
-                <a:solidFill>
-                  <a:srgbClr val="1E242B"/>
-                </a:solidFill>
-                <a:latin typeface="Segoe UI"/>
-              </a:rPr>
-              <a:t>Compiling flattens it into an ordinary protocol document, so the runner, the schedule and session evidence see nothing new</a:t>
-            </a:r>
-          </a:p>
-          <a:p>
-            <a:pPr>
-              <a:spcAft>
-                <a:spcPts val="1300"/>
-              </a:spcAft>
-            </a:pPr>
-            <a:r>
-              <a:rPr sz="1500" b="0" i="0">
-                <a:solidFill>
-                  <a:srgbClr val="1E242B"/>
-                </a:solidFill>
-                <a:latin typeface="Segoe UI"/>
-              </a:rPr>
-              <a:t>Each appearance becomes a named epoch, and the Sources column names the set every value came from</a:t>
-            </a:r>
-          </a:p>
-          <a:p>
-            <a:pPr>
-              <a:spcAft>
-                <a:spcPts val="1300"/>
-              </a:spcAft>
-            </a:pPr>
-            <a:r>
-              <a:rPr sz="1500" b="0" i="0">
-                <a:solidFill>
-                  <a:srgbClr val="1E242B"/>
-                </a:solidFill>
-                <a:latin typeface="Segoe UI"/>
-              </a:rPr>
-              <a:t>Shuffle seeds are stored on the entry, so a compile can always be repeated exactly</a:t>
-            </a:r>
-          </a:p>
-          <a:p>
-            <a:pPr>
-              <a:spcAft>
-                <a:spcPts val="1300"/>
-              </a:spcAft>
-            </a:pPr>
-            <a:r>
-              <a:rPr sz="1500" b="0" i="0">
-                <a:solidFill>
-                  <a:srgbClr val="1E242B"/>
-                </a:solidFill>
-                <a:latin typeface="Segoe UI"/>
-              </a:rPr>
-              <a:t>Editing a set never repins an existing row; a stale pin is visible, and a compile against a changed set is refused rather than silently different</a:t>
-            </a:r>
-          </a:p>
-        </p:txBody>
-      </p:sp>
-      <p:sp>
-        <p:nvSpPr>
-          <p:cNvPr id="4" name="Rectangle 3"/>
-          <p:cNvSpPr/>
-          <p:nvPr/>
-        </p:nvSpPr>
-        <p:spPr>
-          <a:xfrm>
-            <a:off x="658368" y="1170432"/>
-            <a:ext cx="1005840" cy="38100"/>
-          </a:xfrm>
-          <a:prstGeom prst="rect">
-            <a:avLst/>
-          </a:prstGeom>
-          <a:solidFill>
-            <a:srgbClr val="B3593F"/>
-          </a:solidFill>
-          <a:ln>
-            <a:noFill/>
-          </a:ln>
-          <a:effectLst/>
-        </p:spPr>
-        <p:style>
-          <a:lnRef idx="1">
-            <a:schemeClr val="accent1"/>
-          </a:lnRef>
-          <a:fillRef idx="3">
-            <a:schemeClr val="accent1"/>
-          </a:fillRef>
-          <a:effectRef idx="2">
-            <a:schemeClr val="accent1"/>
-          </a:effectRef>
-          <a:fontRef idx="minor">
-            <a:schemeClr val="lt1"/>
-          </a:fontRef>
-        </p:style>
-        <p:txBody>
-          <a:bodyPr rtlCol="0" anchor="ctr"/>
-          <a:lstStyle/>
-          <a:p>
-            <a:pPr algn="ctr"/>
-          </a:p>
-        </p:txBody>
-      </p:sp>
-      <p:sp>
-        <p:nvSpPr>
-          <p:cNvPr id="5" name="TextBox 4"/>
-          <p:cNvSpPr txBox="1"/>
-          <p:nvPr/>
-        </p:nvSpPr>
-        <p:spPr>
-          <a:xfrm>
-            <a:off x="658368" y="1371600"/>
-            <a:ext cx="10874959" cy="457200"/>
-          </a:xfrm>
-          <a:prstGeom prst="rect">
-            <a:avLst/>
-          </a:prstGeom>
-          <a:noFill/>
-        </p:spPr>
-        <p:txBody>
-          <a:bodyPr wrap="square">
-            <a:spAutoFit/>
-          </a:bodyPr>
-          <a:lstStyle/>
-          <a:p>
-            <a:r>
-              <a:rPr sz="1400" b="0" i="1">
-                <a:solidFill>
-                  <a:srgbClr val="6B727B"/>
-                </a:solidFill>
-                <a:latin typeface="Segoe UI"/>
-              </a:rPr>
-              <a:t>A phase shared by several experiments is written once.</a:t>
-            </a:r>
-          </a:p>
-        </p:txBody>
-      </p:sp>
-      <p:sp>
-        <p:nvSpPr>
-          <p:cNvPr id="6" name="TextBox 5"/>
-          <p:cNvSpPr txBox="1"/>
-          <p:nvPr/>
-        </p:nvSpPr>
-        <p:spPr>
-          <a:xfrm>
-            <a:off x="658368" y="6382512"/>
-            <a:ext cx="10874959" cy="292608"/>
-          </a:xfrm>
-          <a:prstGeom prst="rect">
-            <a:avLst/>
-          </a:prstGeom>
-          <a:noFill/>
-        </p:spPr>
-        <p:txBody>
-          <a:bodyPr wrap="none">
-            <a:spAutoFit/>
-          </a:bodyPr>
-          <a:lstStyle/>
-          <a:p>
-            <a:r>
-              <a:rPr sz="900" b="0" i="0">
-                <a:solidFill>
-                  <a:srgbClr val="6B727B"/>
-                </a:solidFill>
-                <a:latin typeface="Segoe UI"/>
-              </a:rPr>
-              <a:t>reachAQ</a:t>
-            </a:r>
-          </a:p>
-        </p:txBody>
-      </p:sp>
-      <p:sp>
-        <p:nvSpPr>
-          <p:cNvPr id="7" name="TextBox 6"/>
-          <p:cNvSpPr txBox="1"/>
-          <p:nvPr/>
-        </p:nvSpPr>
-        <p:spPr>
-          <a:xfrm>
-            <a:off x="10893247" y="6382512"/>
-            <a:ext cx="640080" cy="292608"/>
-          </a:xfrm>
-          <a:prstGeom prst="rect">
-            <a:avLst/>
-          </a:prstGeom>
-          <a:noFill/>
-        </p:spPr>
-        <p:txBody>
-          <a:bodyPr wrap="none">
-            <a:spAutoFit/>
-          </a:bodyPr>
-          <a:lstStyle/>
-          <a:p>
-            <a:pPr algn="r"/>
-            <a:r>
-              <a:rPr sz="900" b="0" i="0">
-                <a:solidFill>
-                  <a:srgbClr val="6B727B"/>
-                </a:solidFill>
-                <a:latin typeface="Segoe UI"/>
-              </a:rPr>
-              <a:t>13</a:t>
-            </a:r>
-          </a:p>
-        </p:txBody>
-      </p:sp>
-    </p:spTree>
-  </p:cSld>
-  <p:clrMapOvr>
-    <a:masterClrMapping/>
-  </p:clrMapOvr>
-</p:sld>
-</file>
-
-<file path=ppt/slides/slide14.xml><?xml version="1.0" encoding="utf-8"?>
-<p:sld xmlns:a="http://schemas.openxmlformats.org/drawingml/2006/main" xmlns:p="http://schemas.openxmlformats.org/presentationml/2006/main" xmlns:r="http://schemas.openxmlformats.org/officeDocument/2006/relationships">
-  <p:cSld>
-    <p:spTree>
-      <p:nvGrpSpPr>
-        <p:cNvPr id="1" name=""/>
-        <p:cNvGrpSpPr/>
-        <p:nvPr/>
-      </p:nvGrpSpPr>
-      <p:grpSpPr/>
-      <p:sp>
-        <p:nvSpPr>
-          <p:cNvPr id="2" name="Title 1"/>
-          <p:cNvSpPr>
-            <a:spLocks noGrp="1"/>
-          </p:cNvSpPr>
-          <p:nvPr>
-            <p:ph type="title"/>
-          </p:nvPr>
-        </p:nvSpPr>
-        <p:spPr>
-          <a:xfrm>
-            <a:off x="658368" y="457200"/>
-            <a:ext cx="10874959" cy="868680"/>
-          </a:xfrm>
-        </p:spPr>
-        <p:txBody>
-          <a:bodyPr wrap="square"/>
-          <a:lstStyle/>
-          <a:p>
-            <a:pPr algn="l"/>
-            <a:r>
-              <a:rPr sz="3000" b="1" i="0">
-                <a:solidFill>
-                  <a:srgbClr val="1E242B"/>
-                </a:solidFill>
-                <a:latin typeface="Segoe UI"/>
-              </a:rPr>
-              <a:t>Demo — recorded video, everything else live</a:t>
-            </a:r>
-          </a:p>
-        </p:txBody>
-      </p:sp>
-      <p:sp>
-        <p:nvSpPr>
-          <p:cNvPr id="3" name="Rectangle 2"/>
-          <p:cNvSpPr/>
-          <p:nvPr/>
-        </p:nvSpPr>
-        <p:spPr>
-          <a:xfrm>
-            <a:off x="658368" y="1170432"/>
-            <a:ext cx="1005840" cy="38100"/>
-          </a:xfrm>
-          <a:prstGeom prst="rect">
-            <a:avLst/>
-          </a:prstGeom>
-          <a:solidFill>
-            <a:srgbClr val="B3593F"/>
-          </a:solidFill>
-          <a:ln>
-            <a:noFill/>
-          </a:ln>
-          <a:effectLst/>
-        </p:spPr>
-        <p:style>
-          <a:lnRef idx="1">
-            <a:schemeClr val="accent1"/>
-          </a:lnRef>
-          <a:fillRef idx="3">
-            <a:schemeClr val="accent1"/>
-          </a:fillRef>
-          <a:effectRef idx="2">
-            <a:schemeClr val="accent1"/>
-          </a:effectRef>
-          <a:fontRef idx="minor">
-            <a:schemeClr val="lt1"/>
-          </a:fontRef>
-        </p:style>
-        <p:txBody>
-          <a:bodyPr rtlCol="0" anchor="ctr"/>
-          <a:lstStyle/>
-          <a:p>
-            <a:pPr algn="ctr"/>
-          </a:p>
-        </p:txBody>
-      </p:sp>
-      <p:sp>
-        <p:nvSpPr>
           <p:cNvPr id="4" name="TextBox 3"/>
           <p:cNvSpPr txBox="1"/>
           <p:nvPr/>
@@ -5893,7 +5195,7 @@
                 </a:solidFill>
                 <a:latin typeface="Segoe UI"/>
               </a:rPr>
-              <a:t>14</a:t>
+              <a:t>12</a:t>
             </a:r>
           </a:p>
         </p:txBody>
@@ -6711,7 +6013,7 @@
                 </a:solidFill>
                 <a:latin typeface="Segoe UI"/>
               </a:rPr>
-              <a:t>The budget</a:t>
+              <a:t>Why pose could not close a loop before</a:t>
             </a:r>
           </a:p>
         </p:txBody>
@@ -6723,13 +6025,13 @@
             <a:spLocks noGrp="1"/>
           </p:cNvSpPr>
           <p:nvPr>
-            <p:ph idx="1"/>
-          </p:nvPr>
-        </p:nvSpPr>
-        <p:spPr>
-          <a:xfrm>
-            <a:off x="658368" y="2057400"/>
-            <a:ext cx="10874959" cy="4023360"/>
+            <p:ph idx="1" sz="half"/>
+          </p:nvPr>
+        </p:nvSpPr>
+        <p:spPr>
+          <a:xfrm>
+            <a:off x="658368" y="2487168"/>
+            <a:ext cx="5186019" cy="3593592"/>
           </a:xfrm>
         </p:spPr>
         <p:txBody>
@@ -6738,72 +6040,125 @@
           <a:p>
             <a:pPr>
               <a:spcAft>
-                <a:spcPts val="1300"/>
+                <a:spcPts val="1100"/>
               </a:spcAft>
             </a:pPr>
             <a:r>
-              <a:rPr sz="1500" b="0" i="0">
+              <a:rPr sz="1350" b="0" i="0">
                 <a:solidFill>
                   <a:srgbClr val="1E242B"/>
                 </a:solidFill>
                 <a:latin typeface="Segoe UI"/>
               </a:rPr>
-              <a:t>Reach cameras run at 150 fps — a 6.667 ms per-frame budget for the perception stream</a:t>
+              <a:t>Reach cameras run at 150 fps — a 6.667 ms per-frame budget for the pose stream</a:t>
             </a:r>
           </a:p>
           <a:p>
             <a:pPr>
               <a:spcAft>
-                <a:spcPts val="1300"/>
+                <a:spcPts val="1100"/>
               </a:spcAft>
             </a:pPr>
             <a:r>
-              <a:rPr sz="1500" b="0" i="0">
+              <a:rPr sz="1350" b="0" i="0">
                 <a:solidFill>
                   <a:srgbClr val="1E242B"/>
                 </a:solidFill>
                 <a:latin typeface="Segoe UI"/>
               </a:rPr>
-              <a:t>The stim camera runs at 900 Hz — a 5 ms budget for the reflex loop. That is a design target and a tail figure, not a measured average</a:t>
+              <a:t>The stim camera runs at 900 Hz — a 5 ms budget for the reflex that fires the laser. That is a design target and a tail figure, not an average</a:t>
             </a:r>
           </a:p>
           <a:p>
             <a:pPr>
               <a:spcAft>
-                <a:spcPts val="1300"/>
+                <a:spcPts val="1100"/>
               </a:spcAft>
             </a:pPr>
             <a:r>
-              <a:rPr sz="1500" b="0" i="0">
+              <a:rPr sz="1350" b="0" i="0">
                 <a:solidFill>
                   <a:srgbClr val="1E242B"/>
                 </a:solidFill>
                 <a:latin typeface="Segoe UI"/>
               </a:rPr>
-              <a:t>The starting point: the DeepLabCut TensorFlow ResNet-50 pose path cost 54.8 ms per batch, about 18 Hz</a:t>
-            </a:r>
-          </a:p>
+              <a:t>The reflex detector's own compute is under 0.1 ms, so its problem was never arithmetic — it was the OS delivering it on time</a:t>
+            </a:r>
+          </a:p>
+        </p:txBody>
+      </p:sp>
+      <p:sp>
+        <p:nvSpPr>
+          <p:cNvPr id="4" name="Content Placeholder 3"/>
+          <p:cNvSpPr>
+            <a:spLocks noGrp="1"/>
+          </p:cNvSpPr>
+          <p:nvPr>
+            <p:ph idx="2" sz="half"/>
+          </p:nvPr>
+        </p:nvSpPr>
+        <p:spPr>
+          <a:xfrm>
+            <a:off x="6347307" y="2487168"/>
+            <a:ext cx="5186019" cy="3593592"/>
+          </a:xfrm>
+        </p:spPr>
+        <p:txBody>
+          <a:bodyPr wrap="square"/>
+          <a:lstStyle/>
           <a:p>
             <a:pPr>
               <a:spcAft>
-                <a:spcPts val="1300"/>
+                <a:spcPts val="1100"/>
               </a:spcAft>
             </a:pPr>
             <a:r>
-              <a:rPr sz="1500" b="0" i="0">
+              <a:rPr sz="1350" b="0" i="0">
                 <a:solidFill>
                   <a:srgbClr val="1E242B"/>
                 </a:solidFill>
                 <a:latin typeface="Segoe UI"/>
               </a:rPr>
-              <a:t>That single number was the largest latency term in the system, and far below camera rate — which is what made pose useless for closing a loop</a:t>
-            </a:r>
-          </a:p>
-        </p:txBody>
-      </p:sp>
-      <p:sp>
-        <p:nvSpPr>
-          <p:cNvPr id="4" name="Rectangle 3"/>
+              <a:t>DeepLabCut on TensorFlow with ResNet-50 cost 54.8 ms per batch — about 18 Hz</a:t>
+            </a:r>
+          </a:p>
+          <a:p>
+            <a:pPr>
+              <a:spcAft>
+                <a:spcPts val="1100"/>
+              </a:spcAft>
+            </a:pPr>
+            <a:r>
+              <a:rPr sz="1350" b="0" i="0">
+                <a:solidFill>
+                  <a:srgbClr val="1E242B"/>
+                </a:solidFill>
+                <a:latin typeface="Segoe UI"/>
+              </a:rPr>
+              <a:t>That was the largest single latency term in the system, and roughly eight times over the frame budget</a:t>
+            </a:r>
+          </a:p>
+          <a:p>
+            <a:pPr>
+              <a:spcAft>
+                <a:spcPts val="1100"/>
+              </a:spcAft>
+            </a:pPr>
+            <a:r>
+              <a:rPr sz="1350" b="0" i="0">
+                <a:solidFill>
+                  <a:srgbClr val="1E242B"/>
+                </a:solidFill>
+                <a:latin typeface="Segoe UI"/>
+              </a:rPr>
+              <a:t>Pose could describe behaviour afterwards, but nothing could be decided from it while the reach was happening</a:t>
+            </a:r>
+          </a:p>
+        </p:txBody>
+      </p:sp>
+      <p:sp>
+        <p:nvSpPr>
+          <p:cNvPr id="5" name="Rectangle 4"/>
           <p:cNvSpPr/>
           <p:nvPr/>
         </p:nvSpPr>
@@ -6847,7 +6202,7 @@
       </p:sp>
       <p:sp>
         <p:nvSpPr>
-          <p:cNvPr id="5" name="TextBox 4"/>
+          <p:cNvPr id="6" name="TextBox 5"/>
           <p:cNvSpPr txBox="1"/>
           <p:nvPr/>
         </p:nvSpPr>
@@ -6874,21 +6229,21 @@
                 </a:solidFill>
                 <a:latin typeface="Segoe UI"/>
               </a:rPr>
-              <a:t>Two cameras, two clocks, two very different deadlines.</a:t>
-            </a:r>
-          </a:p>
-        </p:txBody>
-      </p:sp>
-      <p:sp>
-        <p:nvSpPr>
-          <p:cNvPr id="6" name="TextBox 5"/>
+              <a:t>Two cameras, two deadlines. The pose path missed its by a factor of eight.</a:t>
+            </a:r>
+          </a:p>
+        </p:txBody>
+      </p:sp>
+      <p:sp>
+        <p:nvSpPr>
+          <p:cNvPr id="7" name="TextBox 6"/>
           <p:cNvSpPr txBox="1"/>
           <p:nvPr/>
         </p:nvSpPr>
         <p:spPr>
           <a:xfrm>
-            <a:off x="658368" y="6382512"/>
-            <a:ext cx="10874959" cy="292608"/>
+            <a:off x="658368" y="2103120"/>
+            <a:ext cx="5186019" cy="347472"/>
           </a:xfrm>
           <a:prstGeom prst="rect">
             <a:avLst/>
@@ -6902,6 +6257,74 @@
           <a:lstStyle/>
           <a:p>
             <a:r>
+              <a:rPr sz="1500" b="1" i="0">
+                <a:solidFill>
+                  <a:srgbClr val="6B7F9E"/>
+                </a:solidFill>
+                <a:latin typeface="Segoe UI"/>
+              </a:rPr>
+              <a:t>What has to be fast</a:t>
+            </a:r>
+          </a:p>
+        </p:txBody>
+      </p:sp>
+      <p:sp>
+        <p:nvSpPr>
+          <p:cNvPr id="8" name="TextBox 7"/>
+          <p:cNvSpPr txBox="1"/>
+          <p:nvPr/>
+        </p:nvSpPr>
+        <p:spPr>
+          <a:xfrm>
+            <a:off x="6347307" y="2103120"/>
+            <a:ext cx="5186019" cy="347472"/>
+          </a:xfrm>
+          <a:prstGeom prst="rect">
+            <a:avLst/>
+          </a:prstGeom>
+          <a:noFill/>
+        </p:spPr>
+        <p:txBody>
+          <a:bodyPr wrap="none">
+            <a:spAutoFit/>
+          </a:bodyPr>
+          <a:lstStyle/>
+          <a:p>
+            <a:r>
+              <a:rPr sz="1500" b="1" i="0">
+                <a:solidFill>
+                  <a:srgbClr val="B3593F"/>
+                </a:solidFill>
+                <a:latin typeface="Segoe UI"/>
+              </a:rPr>
+              <a:t>Where it started</a:t>
+            </a:r>
+          </a:p>
+        </p:txBody>
+      </p:sp>
+      <p:sp>
+        <p:nvSpPr>
+          <p:cNvPr id="9" name="TextBox 8"/>
+          <p:cNvSpPr txBox="1"/>
+          <p:nvPr/>
+        </p:nvSpPr>
+        <p:spPr>
+          <a:xfrm>
+            <a:off x="658368" y="6382512"/>
+            <a:ext cx="10874959" cy="292608"/>
+          </a:xfrm>
+          <a:prstGeom prst="rect">
+            <a:avLst/>
+          </a:prstGeom>
+          <a:noFill/>
+        </p:spPr>
+        <p:txBody>
+          <a:bodyPr wrap="none">
+            <a:spAutoFit/>
+          </a:bodyPr>
+          <a:lstStyle/>
+          <a:p>
+            <a:r>
               <a:rPr sz="900" b="0" i="0">
                 <a:solidFill>
                   <a:srgbClr val="6B727B"/>
@@ -6915,7 +6338,7 @@
       </p:sp>
       <p:sp>
         <p:nvSpPr>
-          <p:cNvPr id="7" name="TextBox 6"/>
+          <p:cNvPr id="10" name="TextBox 9"/>
           <p:cNvSpPr txBox="1"/>
           <p:nvPr/>
         </p:nvSpPr>
@@ -6994,7 +6417,7 @@
                 </a:solidFill>
                 <a:latin typeface="Segoe UI"/>
               </a:rPr>
-              <a:t>Two tiers, not one fast path</a:t>
+              <a:t>What we changed</a:t>
             </a:r>
           </a:p>
         </p:txBody>
@@ -7006,13 +6429,13 @@
             <a:spLocks noGrp="1"/>
           </p:cNvSpPr>
           <p:nvPr>
-            <p:ph idx="1" sz="half"/>
-          </p:nvPr>
-        </p:nvSpPr>
-        <p:spPr>
-          <a:xfrm>
-            <a:off x="658368" y="2487168"/>
-            <a:ext cx="5186019" cy="3593592"/>
+            <p:ph idx="1"/>
+          </p:nvPr>
+        </p:nvSpPr>
+        <p:spPr>
+          <a:xfrm>
+            <a:off x="658368" y="2057400"/>
+            <a:ext cx="10874959" cy="4023360"/>
           </a:xfrm>
         </p:spPr>
         <p:txBody>
@@ -7021,125 +6444,104 @@
           <a:p>
             <a:pPr>
               <a:spcAft>
-                <a:spcPts val="1100"/>
+                <a:spcPts val="1300"/>
               </a:spcAft>
             </a:pPr>
             <a:r>
-              <a:rPr sz="1350" b="0" i="0">
+              <a:rPr sz="1500" b="0" i="0">
                 <a:solidFill>
                   <a:srgbClr val="1E242B"/>
                 </a:solidFill>
                 <a:latin typeface="Segoe UI"/>
               </a:rPr>
-              <a:t>The stim camera's first-reach detector triggers the laser</a:t>
+              <a:t>Split the work in two. The reflex loop keeps its millisecond deadline; the pose stream is allowed to run slower than the cameras, because it informs behaviour rather than firing hardware</a:t>
             </a:r>
           </a:p>
           <a:p>
             <a:pPr>
               <a:spcAft>
-                <a:spcPts val="1100"/>
+                <a:spcPts val="1300"/>
               </a:spcAft>
             </a:pPr>
             <a:r>
-              <a:rPr sz="1350" b="0" i="0">
+              <a:rPr sz="1500" b="0" i="0">
                 <a:solidFill>
                   <a:srgbClr val="1E242B"/>
                 </a:solidFill>
                 <a:latin typeface="Segoe UI"/>
               </a:rPr>
-              <a:t>This is the path that genuinely must be fast</a:t>
+              <a:t>Gave the reflex loop real-time scheduling (SCHED_FIFO) and a performance CPU governor, so a busy machine cannot delay it</a:t>
             </a:r>
           </a:p>
           <a:p>
             <a:pPr>
               <a:spcAft>
-                <a:spcPts val="1100"/>
+                <a:spcPts val="1300"/>
               </a:spcAft>
             </a:pPr>
             <a:r>
-              <a:rPr sz="1350" b="0" i="0">
+              <a:rPr sz="1500" b="0" i="0">
                 <a:solidFill>
                   <a:srgbClr val="1E242B"/>
                 </a:solidFill>
                 <a:latin typeface="Segoe UI"/>
               </a:rPr>
-              <a:t>Its own compute is under 0.1 ms, so the work was making the OS deliver it on time, not making it compute less</a:t>
-            </a:r>
-          </a:p>
-        </p:txBody>
-      </p:sp>
-      <p:sp>
-        <p:nvSpPr>
-          <p:cNvPr id="4" name="Content Placeholder 3"/>
-          <p:cNvSpPr>
-            <a:spLocks noGrp="1"/>
-          </p:cNvSpPr>
-          <p:nvPr>
-            <p:ph idx="2" sz="half"/>
-          </p:nvPr>
-        </p:nvSpPr>
-        <p:spPr>
-          <a:xfrm>
-            <a:off x="6347307" y="2487168"/>
-            <a:ext cx="5186019" cy="3593592"/>
-          </a:xfrm>
-        </p:spPr>
-        <p:txBody>
-          <a:bodyPr wrap="square"/>
-          <a:lstStyle/>
+              <a:t>Stopped padding the inference batch — run the 2 real frames instead of a padded 6 — and rewrote the CPU decode to use argmax and numpy instead of a sort and pandas</a:t>
+            </a:r>
+          </a:p>
           <a:p>
             <a:pPr>
               <a:spcAft>
-                <a:spcPts val="1100"/>
+                <a:spcPts val="1300"/>
               </a:spcAft>
             </a:pPr>
             <a:r>
-              <a:rPr sz="1350" b="0" i="0">
+              <a:rPr sz="1500" b="0" i="0">
                 <a:solidFill>
                   <a:srgbClr val="1E242B"/>
                 </a:solidFill>
                 <a:latin typeface="Segoe UI"/>
               </a:rPr>
-              <a:t>The reach-camera pose stream, informing behaviour and gating</a:t>
+              <a:t>Captured the CUDA graph for the live batch and replayed it, instead of re-submitting the same work every call</a:t>
             </a:r>
           </a:p>
           <a:p>
             <a:pPr>
               <a:spcAft>
-                <a:spcPts val="1100"/>
+                <a:spcPts val="1300"/>
               </a:spcAft>
             </a:pPr>
             <a:r>
-              <a:rPr sz="1350" b="0" i="0">
+              <a:rPr sz="1500" b="0" i="0">
                 <a:solidFill>
                   <a:srgbClr val="1E242B"/>
                 </a:solidFill>
                 <a:latin typeface="Segoe UI"/>
               </a:rPr>
-              <a:t>It does not have to hit camera rate to be useful</a:t>
+              <a:t>Made the pose stage unable to hurt acquisition: it takes frames on a separate non-blocking queue, always takes the newest and drops stale ones, so latency never grows into a backlog</a:t>
             </a:r>
           </a:p>
           <a:p>
             <a:pPr>
               <a:spcAft>
-                <a:spcPts val="1100"/>
+                <a:spcPts val="1300"/>
               </a:spcAft>
             </a:pPr>
             <a:r>
-              <a:rPr sz="1350" b="0" i="0">
+              <a:rPr sz="1500" b="0" i="0">
                 <a:solidFill>
                   <a:srgbClr val="1E242B"/>
                 </a:solidFill>
                 <a:latin typeface="Segoe UI"/>
               </a:rPr>
-              <a:t>Accepting that is what let an accuracy decision beat a raw-speed one</a:t>
-            </a:r>
-          </a:p>
-        </p:txBody>
-      </p:sp>
-      <p:sp>
-        <p:nvSpPr>
-          <p:cNvPr id="5" name="Rectangle 4"/>
+              <a:t>Tried the usual accelerators and kept none of them — fp16, torch.compile and ONNX Runtime all measured at or below parity on this card, and TensorRT's real 1.3x was not worth a second inference path</a:t>
+            </a:r>
+          </a:p>
+        </p:txBody>
+      </p:sp>
+      <p:sp>
+        <p:nvSpPr>
+          <p:cNvPr id="4" name="Rectangle 3"/>
           <p:cNvSpPr/>
           <p:nvPr/>
         </p:nvSpPr>
@@ -7183,7 +6585,7 @@
       </p:sp>
       <p:sp>
         <p:nvSpPr>
-          <p:cNvPr id="6" name="TextBox 5"/>
+          <p:cNvPr id="5" name="TextBox 4"/>
           <p:cNvSpPr txBox="1"/>
           <p:nvPr/>
         </p:nvSpPr>
@@ -7210,21 +6612,21 @@
                 </a:solidFill>
                 <a:latin typeface="Segoe UI"/>
               </a:rPr>
-              <a:t>We did not make one model fast enough for everything. We separated the millisecond-critical reflex from the perception stream and optimised each to its own budget.</a:t>
-            </a:r>
-          </a:p>
-        </p:txBody>
-      </p:sp>
-      <p:sp>
-        <p:nvSpPr>
-          <p:cNvPr id="7" name="TextBox 6"/>
+              <a:t>The wins came from removing our own overhead and letting each tier meet its own deadline — not from a faster runtime.</a:t>
+            </a:r>
+          </a:p>
+        </p:txBody>
+      </p:sp>
+      <p:sp>
+        <p:nvSpPr>
+          <p:cNvPr id="6" name="TextBox 5"/>
           <p:cNvSpPr txBox="1"/>
           <p:nvPr/>
         </p:nvSpPr>
         <p:spPr>
           <a:xfrm>
-            <a:off x="658368" y="2103120"/>
-            <a:ext cx="5186019" cy="347472"/>
+            <a:off x="658368" y="6382512"/>
+            <a:ext cx="10874959" cy="292608"/>
           </a:xfrm>
           <a:prstGeom prst="rect">
             <a:avLst/>
@@ -7238,74 +6640,6 @@
           <a:lstStyle/>
           <a:p>
             <a:r>
-              <a:rPr sz="1500" b="1" i="0">
-                <a:solidFill>
-                  <a:srgbClr val="6B7F9E"/>
-                </a:solidFill>
-                <a:latin typeface="Segoe UI"/>
-              </a:rPr>
-              <a:t>Tier 1 — reflex</a:t>
-            </a:r>
-          </a:p>
-        </p:txBody>
-      </p:sp>
-      <p:sp>
-        <p:nvSpPr>
-          <p:cNvPr id="8" name="TextBox 7"/>
-          <p:cNvSpPr txBox="1"/>
-          <p:nvPr/>
-        </p:nvSpPr>
-        <p:spPr>
-          <a:xfrm>
-            <a:off x="6347307" y="2103120"/>
-            <a:ext cx="5186019" cy="347472"/>
-          </a:xfrm>
-          <a:prstGeom prst="rect">
-            <a:avLst/>
-          </a:prstGeom>
-          <a:noFill/>
-        </p:spPr>
-        <p:txBody>
-          <a:bodyPr wrap="none">
-            <a:spAutoFit/>
-          </a:bodyPr>
-          <a:lstStyle/>
-          <a:p>
-            <a:r>
-              <a:rPr sz="1500" b="1" i="0">
-                <a:solidFill>
-                  <a:srgbClr val="B3593F"/>
-                </a:solidFill>
-                <a:latin typeface="Segoe UI"/>
-              </a:rPr>
-              <a:t>Tier 2 — perception</a:t>
-            </a:r>
-          </a:p>
-        </p:txBody>
-      </p:sp>
-      <p:sp>
-        <p:nvSpPr>
-          <p:cNvPr id="9" name="TextBox 8"/>
-          <p:cNvSpPr txBox="1"/>
-          <p:nvPr/>
-        </p:nvSpPr>
-        <p:spPr>
-          <a:xfrm>
-            <a:off x="658368" y="6382512"/>
-            <a:ext cx="10874959" cy="292608"/>
-          </a:xfrm>
-          <a:prstGeom prst="rect">
-            <a:avLst/>
-          </a:prstGeom>
-          <a:noFill/>
-        </p:spPr>
-        <p:txBody>
-          <a:bodyPr wrap="none">
-            <a:spAutoFit/>
-          </a:bodyPr>
-          <a:lstStyle/>
-          <a:p>
-            <a:r>
               <a:rPr sz="900" b="0" i="0">
                 <a:solidFill>
                   <a:srgbClr val="6B727B"/>
@@ -7319,7 +6653,7 @@
       </p:sp>
       <p:sp>
         <p:nvSpPr>
-          <p:cNvPr id="10" name="TextBox 9"/>
+          <p:cNvPr id="7" name="TextBox 6"/>
           <p:cNvSpPr txBox="1"/>
           <p:nvPr/>
         </p:nvSpPr>
@@ -7398,7 +6732,7 @@
                 </a:solidFill>
                 <a:latin typeface="Segoe UI"/>
               </a:rPr>
-              <a:t>Tier 1 — making the reflex land on time</a:t>
+              <a:t>What it measured</a:t>
             </a:r>
           </a:p>
         </p:txBody>
@@ -7476,14 +6810,14 @@
                 </a:solidFill>
                 <a:latin typeface="Segoe UI"/>
               </a:rPr>
-              <a:t>The detector's own compute never exceeds 0.09 ms. The entire problem was scheduler wake-up latency under load.</a:t>
+              <a:t>Same rig, same load, before and after each change.</a:t>
             </a:r>
           </a:p>
         </p:txBody>
       </p:sp>
       <p:pic>
         <p:nvPicPr>
-          <p:cNvPr id="5" name="Picture 4" descr="stim_latency.png"/>
+          <p:cNvPr id="5" name="Picture 4" descr="measurements.png"/>
           <p:cNvPicPr>
             <a:picLocks noChangeAspect="1"/>
           </p:cNvPicPr>
@@ -7497,8 +6831,8 @@
         </p:blipFill>
         <p:spPr>
           <a:xfrm>
-            <a:off x="2092711" y="1847088"/>
-            <a:ext cx="8006272" cy="3822192"/>
+            <a:off x="975777" y="1847088"/>
+            <a:ext cx="10240140" cy="3822192"/>
           </a:xfrm>
           <a:prstGeom prst="rect">
             <a:avLst/>
@@ -7535,7 +6869,7 @@
                 </a:solidFill>
                 <a:latin typeface="Segoe UI"/>
               </a:rPr>
-              <a:t>Under a 16-process load, real-time scheduling took the worst case from 6.05 ms to 0.155 ms, with zero missed deadlines and the full 900 Hz cadence restored.</a:t>
+              <a:t>Measured on an NVIDIA T1000 — a low-end Turing card with no tensor cores, which is why fp16 lost here and why a tensor-core GPU would shift several of these numbers.</a:t>
             </a:r>
           </a:p>
         </p:txBody>
@@ -7655,14 +6989,152 @@
                 </a:solidFill>
                 <a:latin typeface="Segoe UI"/>
               </a:rPr>
-              <a:t>Tier 2 — where the milliseconds went</a:t>
-            </a:r>
-          </a:p>
-        </p:txBody>
-      </p:sp>
-      <p:sp>
-        <p:nvSpPr>
-          <p:cNvPr id="3" name="Rectangle 2"/>
+              <a:t>Pick the model that fits the experiment</a:t>
+            </a:r>
+          </a:p>
+        </p:txBody>
+      </p:sp>
+      <p:sp>
+        <p:nvSpPr>
+          <p:cNvPr id="3" name="Content Placeholder 2"/>
+          <p:cNvSpPr>
+            <a:spLocks noGrp="1"/>
+          </p:cNvSpPr>
+          <p:nvPr>
+            <p:ph idx="1" sz="half"/>
+          </p:nvPr>
+        </p:nvSpPr>
+        <p:spPr>
+          <a:xfrm>
+            <a:off x="658368" y="2487168"/>
+            <a:ext cx="5186019" cy="3593592"/>
+          </a:xfrm>
+        </p:spPr>
+        <p:txBody>
+          <a:bodyPr wrap="square"/>
+          <a:lstStyle/>
+          <a:p>
+            <a:pPr>
+              <a:spcAft>
+                <a:spcPts val="1100"/>
+              </a:spcAft>
+            </a:pPr>
+            <a:r>
+              <a:rPr sz="1350" b="0" i="0">
+                <a:solidFill>
+                  <a:srgbClr val="1E242B"/>
+                </a:solidFill>
+                <a:latin typeface="Segoe UI"/>
+              </a:rPr>
+              <a:t>YOLO — the current default, and the one the CUDA-graph path accelerates</a:t>
+            </a:r>
+          </a:p>
+          <a:p>
+            <a:pPr>
+              <a:spcAft>
+                <a:spcPts val="1100"/>
+              </a:spcAft>
+            </a:pPr>
+            <a:r>
+              <a:rPr sz="1350" b="0" i="0">
+                <a:solidFill>
+                  <a:srgbClr val="1E242B"/>
+                </a:solidFill>
+                <a:latin typeface="Segoe UI"/>
+              </a:rPr>
+              <a:t>cspnext and rtmpose — top-down pose families with measured confidence thresholds per backbone</a:t>
+            </a:r>
+          </a:p>
+          <a:p>
+            <a:pPr>
+              <a:spcAft>
+                <a:spcPts val="1100"/>
+              </a:spcAft>
+            </a:pPr>
+            <a:r>
+              <a:rPr sz="1350" b="0" i="0">
+                <a:solidFill>
+                  <a:srgbClr val="1E242B"/>
+                </a:solidFill>
+                <a:latin typeface="Segoe UI"/>
+              </a:rPr>
+              <a:t>DeepLabCut ResNet-50 — the accuracy reference, and where this started</a:t>
+            </a:r>
+          </a:p>
+        </p:txBody>
+      </p:sp>
+      <p:sp>
+        <p:nvSpPr>
+          <p:cNvPr id="4" name="Content Placeholder 3"/>
+          <p:cNvSpPr>
+            <a:spLocks noGrp="1"/>
+          </p:cNvSpPr>
+          <p:nvPr>
+            <p:ph idx="2" sz="half"/>
+          </p:nvPr>
+        </p:nvSpPr>
+        <p:spPr>
+          <a:xfrm>
+            <a:off x="6347307" y="2487168"/>
+            <a:ext cx="5186019" cy="3593592"/>
+          </a:xfrm>
+        </p:spPr>
+        <p:txBody>
+          <a:bodyPr wrap="square"/>
+          <a:lstStyle/>
+          <a:p>
+            <a:pPr>
+              <a:spcAft>
+                <a:spcPts val="1100"/>
+              </a:spcAft>
+            </a:pPr>
+            <a:r>
+              <a:rPr sz="1350" b="0" i="0">
+                <a:solidFill>
+                  <a:srgbClr val="1E242B"/>
+                </a:solidFill>
+                <a:latin typeface="Segoe UI"/>
+              </a:rPr>
+              <a:t>Faster backbones hold camera rate: cspnext_s sustains 150 fps at 7.66 ms sensor-to-pose; cspnext_m runs near 103 fps</a:t>
+            </a:r>
+          </a:p>
+          <a:p>
+            <a:pPr>
+              <a:spcAft>
+                <a:spcPts val="1100"/>
+              </a:spcAft>
+            </a:pPr>
+            <a:r>
+              <a:rPr sz="1350" b="0" i="0">
+                <a:solidFill>
+                  <a:srgbClr val="1E242B"/>
+                </a:solidFill>
+                <a:latin typeface="Segoe UI"/>
+              </a:rPr>
+              <a:t>ResNet-50 runs below camera rate on this GPU — fine for a behaviour stream, not for closing a loop</a:t>
+            </a:r>
+          </a:p>
+          <a:p>
+            <a:pPr>
+              <a:spcAft>
+                <a:spcPts val="1100"/>
+              </a:spcAft>
+            </a:pPr>
+            <a:r>
+              <a:rPr sz="1350" b="0" i="0">
+                <a:solidFill>
+                  <a:srgbClr val="1E242B"/>
+                </a:solidFill>
+                <a:latin typeface="Segoe UI"/>
+              </a:rPr>
+              <a:t>Confidence does not mean the same thing across families, so the gate threshold is measured per backbone rather than set globally</a:t>
+            </a:r>
+          </a:p>
+        </p:txBody>
+      </p:sp>
+      <p:sp>
+        <p:nvSpPr>
+          <p:cNvPr id="5" name="Rectangle 4"/>
           <p:cNvSpPr/>
           <p:nvPr/>
         </p:nvSpPr>
@@ -7706,7 +7178,7 @@
       </p:sp>
       <p:sp>
         <p:nvSpPr>
-          <p:cNvPr id="4" name="TextBox 3"/>
+          <p:cNvPr id="6" name="TextBox 5"/>
           <p:cNvSpPr txBox="1"/>
           <p:nvPr/>
         </p:nvSpPr>
@@ -7733,45 +7205,21 @@
                 </a:solidFill>
                 <a:latin typeface="Segoe UI"/>
               </a:rPr>
-              <a:t>The speed came from removing our own overhead and choosing the right architecture.</a:t>
-            </a:r>
-          </a:p>
-        </p:txBody>
-      </p:sp>
-      <p:pic>
-        <p:nvPicPr>
-          <p:cNvPr id="5" name="Picture 4" descr="inference_ladder.png"/>
-          <p:cNvPicPr>
-            <a:picLocks noChangeAspect="1"/>
-          </p:cNvPicPr>
-          <p:nvPr/>
-        </p:nvPicPr>
-        <p:blipFill>
-          <a:blip r:embed="rId2"/>
-          <a:stretch>
-            <a:fillRect/>
-          </a:stretch>
-        </p:blipFill>
-        <p:spPr>
-          <a:xfrm>
-            <a:off x="911580" y="1847088"/>
-            <a:ext cx="10368534" cy="3822192"/>
-          </a:xfrm>
-          <a:prstGeom prst="rect">
-            <a:avLst/>
-          </a:prstGeom>
-        </p:spPr>
-      </p:pic>
-      <p:sp>
-        <p:nvSpPr>
-          <p:cNvPr id="6" name="TextBox 5"/>
+              <a:t>The backend takes several model families. Speed and accuracy trade against each other, and the choice is yours per use case.</a:t>
+            </a:r>
+          </a:p>
+        </p:txBody>
+      </p:sp>
+      <p:sp>
+        <p:nvSpPr>
+          <p:cNvPr id="7" name="TextBox 6"/>
           <p:cNvSpPr txBox="1"/>
           <p:nvPr/>
         </p:nvSpPr>
         <p:spPr>
           <a:xfrm>
-            <a:off x="658368" y="5797296"/>
-            <a:ext cx="10874959" cy="502920"/>
+            <a:off x="658368" y="2103120"/>
+            <a:ext cx="5186019" cy="347472"/>
           </a:xfrm>
           <a:prstGeom prst="rect">
             <a:avLst/>
@@ -7779,34 +7227,33 @@
           <a:noFill/>
         </p:spPr>
         <p:txBody>
-          <a:bodyPr wrap="square">
+          <a:bodyPr wrap="none">
             <a:spAutoFit/>
           </a:bodyPr>
           <a:lstStyle/>
           <a:p>
-            <a:pPr algn="ctr"/>
-            <a:r>
-              <a:rPr sz="1150" b="0" i="1">
-                <a:solidFill>
-                  <a:srgbClr val="6B727B"/>
-                </a:solidFill>
-                <a:latin typeface="Segoe UI"/>
-              </a:rPr>
-              <a:t>Colour is status, not just result. The mobile-class backbone was measured at about 8x and deliberately not adopted — its confidence does not predict accuracy, which would break the 3D confidence gate.</a:t>
-            </a:r>
-          </a:p>
-        </p:txBody>
-      </p:sp>
-      <p:sp>
-        <p:nvSpPr>
-          <p:cNvPr id="7" name="TextBox 6"/>
+            <a:r>
+              <a:rPr sz="1500" b="1" i="0">
+                <a:solidFill>
+                  <a:srgbClr val="6B7F9E"/>
+                </a:solidFill>
+                <a:latin typeface="Segoe UI"/>
+              </a:rPr>
+              <a:t>What you get to choose</a:t>
+            </a:r>
+          </a:p>
+        </p:txBody>
+      </p:sp>
+      <p:sp>
+        <p:nvSpPr>
+          <p:cNvPr id="8" name="TextBox 7"/>
           <p:cNvSpPr txBox="1"/>
           <p:nvPr/>
         </p:nvSpPr>
         <p:spPr>
           <a:xfrm>
-            <a:off x="658368" y="6382512"/>
-            <a:ext cx="10874959" cy="292608"/>
+            <a:off x="6347307" y="2103120"/>
+            <a:ext cx="5186019" cy="347472"/>
           </a:xfrm>
           <a:prstGeom prst="rect">
             <a:avLst/>
@@ -7820,6 +7267,40 @@
           <a:lstStyle/>
           <a:p>
             <a:r>
+              <a:rPr sz="1500" b="1" i="0">
+                <a:solidFill>
+                  <a:srgbClr val="B3593F"/>
+                </a:solidFill>
+                <a:latin typeface="Segoe UI"/>
+              </a:rPr>
+              <a:t>What the choice costs</a:t>
+            </a:r>
+          </a:p>
+        </p:txBody>
+      </p:sp>
+      <p:sp>
+        <p:nvSpPr>
+          <p:cNvPr id="9" name="TextBox 8"/>
+          <p:cNvSpPr txBox="1"/>
+          <p:nvPr/>
+        </p:nvSpPr>
+        <p:spPr>
+          <a:xfrm>
+            <a:off x="658368" y="6382512"/>
+            <a:ext cx="10874959" cy="292608"/>
+          </a:xfrm>
+          <a:prstGeom prst="rect">
+            <a:avLst/>
+          </a:prstGeom>
+          <a:noFill/>
+        </p:spPr>
+        <p:txBody>
+          <a:bodyPr wrap="none">
+            <a:spAutoFit/>
+          </a:bodyPr>
+          <a:lstStyle/>
+          <a:p>
+            <a:r>
               <a:rPr sz="900" b="0" i="0">
                 <a:solidFill>
                   <a:srgbClr val="6B727B"/>
@@ -7833,7 +7314,7 @@
       </p:sp>
       <p:sp>
         <p:nvSpPr>
-          <p:cNvPr id="8" name="TextBox 7"/>
+          <p:cNvPr id="10" name="TextBox 9"/>
           <p:cNvSpPr txBox="1"/>
           <p:nvPr/>
         </p:nvSpPr>
@@ -7912,14 +7393,184 @@
                 </a:solidFill>
                 <a:latin typeface="Segoe UI"/>
               </a:rPr>
-              <a:t>One OS setting was worth six more milliseconds</a:t>
-            </a:r>
-          </a:p>
-        </p:txBody>
-      </p:sp>
-      <p:sp>
-        <p:nvSpPr>
-          <p:cNvPr id="3" name="Rectangle 2"/>
+              <a:t>What this buys, and what it costs</a:t>
+            </a:r>
+          </a:p>
+        </p:txBody>
+      </p:sp>
+      <p:sp>
+        <p:nvSpPr>
+          <p:cNvPr id="3" name="Content Placeholder 2"/>
+          <p:cNvSpPr>
+            <a:spLocks noGrp="1"/>
+          </p:cNvSpPr>
+          <p:nvPr>
+            <p:ph idx="1" sz="half"/>
+          </p:nvPr>
+        </p:nvSpPr>
+        <p:spPr>
+          <a:xfrm>
+            <a:off x="658368" y="2487168"/>
+            <a:ext cx="5186019" cy="3593592"/>
+          </a:xfrm>
+        </p:spPr>
+        <p:txBody>
+          <a:bodyPr wrap="square"/>
+          <a:lstStyle/>
+          <a:p>
+            <a:pPr>
+              <a:spcAft>
+                <a:spcPts val="1100"/>
+              </a:spcAft>
+            </a:pPr>
+            <a:r>
+              <a:rPr sz="1350" b="0" i="0">
+                <a:solidFill>
+                  <a:srgbClr val="1E242B"/>
+                </a:solidFill>
+                <a:latin typeface="Segoe UI"/>
+              </a:rPr>
+              <a:t>A second closed loop driven by machine vision, alongside the fast ROI reflex — decisions can now depend on where the paw actually is</a:t>
+            </a:r>
+          </a:p>
+          <a:p>
+            <a:pPr>
+              <a:spcAft>
+                <a:spcPts val="1100"/>
+              </a:spcAft>
+            </a:pPr>
+            <a:r>
+              <a:rPr sz="1350" b="0" i="0">
+                <a:solidFill>
+                  <a:srgbClr val="1E242B"/>
+                </a:solidFill>
+                <a:latin typeface="Segoe UI"/>
+              </a:rPr>
+              <a:t>A live 2D pose overlay per camera view while the session runs</a:t>
+            </a:r>
+          </a:p>
+          <a:p>
+            <a:pPr>
+              <a:spcAft>
+                <a:spcPts val="1100"/>
+              </a:spcAft>
+            </a:pPr>
+            <a:r>
+              <a:rPr sz="1350" b="0" i="0">
+                <a:solidFill>
+                  <a:srgbClr val="1E242B"/>
+                </a:solidFill>
+                <a:latin typeface="Segoe UI"/>
+              </a:rPr>
+              <a:t>Signals visualised during acquisition instead of plotted afterwards</a:t>
+            </a:r>
+          </a:p>
+          <a:p>
+            <a:pPr>
+              <a:spcAft>
+                <a:spcPts val="1100"/>
+              </a:spcAft>
+            </a:pPr>
+            <a:r>
+              <a:rPr sz="1350" b="0" i="0">
+                <a:solidFill>
+                  <a:srgbClr val="1E242B"/>
+                </a:solidFill>
+                <a:latin typeface="Segoe UI"/>
+              </a:rPr>
+              <a:t>Experiments composed from reusable trial sets, with reproducible draws</a:t>
+            </a:r>
+          </a:p>
+        </p:txBody>
+      </p:sp>
+      <p:sp>
+        <p:nvSpPr>
+          <p:cNvPr id="4" name="Content Placeholder 3"/>
+          <p:cNvSpPr>
+            <a:spLocks noGrp="1"/>
+          </p:cNvSpPr>
+          <p:nvPr>
+            <p:ph idx="2" sz="half"/>
+          </p:nvPr>
+        </p:nvSpPr>
+        <p:spPr>
+          <a:xfrm>
+            <a:off x="6347307" y="2487168"/>
+            <a:ext cx="5186019" cy="3593592"/>
+          </a:xfrm>
+        </p:spPr>
+        <p:txBody>
+          <a:bodyPr wrap="square"/>
+          <a:lstStyle/>
+          <a:p>
+            <a:pPr>
+              <a:spcAft>
+                <a:spcPts val="1100"/>
+              </a:spcAft>
+            </a:pPr>
+            <a:r>
+              <a:rPr sz="1350" b="0" i="0">
+                <a:solidFill>
+                  <a:srgbClr val="1E242B"/>
+                </a:solidFill>
+                <a:latin typeface="Segoe UI"/>
+              </a:rPr>
+              <a:t>A working CUDA GPU. Live inference refuses to start without one, by design, rather than silently running slow</a:t>
+            </a:r>
+          </a:p>
+          <a:p>
+            <a:pPr>
+              <a:spcAft>
+                <a:spcPts val="1100"/>
+              </a:spcAft>
+            </a:pPr>
+            <a:r>
+              <a:rPr sz="1350" b="0" i="0">
+                <a:solidFill>
+                  <a:srgbClr val="1E242B"/>
+                </a:solidFill>
+                <a:latin typeface="Segoe UI"/>
+              </a:rPr>
+              <a:t>Two settings the installer applies: real-time scheduling for the reflex loop and the performance CPU governor</a:t>
+            </a:r>
+          </a:p>
+          <a:p>
+            <a:pPr>
+              <a:spcAft>
+                <a:spcPts val="1100"/>
+              </a:spcAft>
+            </a:pPr>
+            <a:r>
+              <a:rPr sz="1350" b="0" i="0">
+                <a:solidFill>
+                  <a:srgbClr val="1E242B"/>
+                </a:solidFill>
+                <a:latin typeface="Segoe UI"/>
+              </a:rPr>
+              <a:t>Calibration that matches the geometry the cameras actually record, or 3D is wrong beneath a correct-looking 2D overlay</a:t>
+            </a:r>
+          </a:p>
+          <a:p>
+            <a:pPr>
+              <a:spcAft>
+                <a:spcPts val="1100"/>
+              </a:spcAft>
+            </a:pPr>
+            <a:r>
+              <a:rPr sz="1350" b="0" i="0">
+                <a:solidFill>
+                  <a:srgbClr val="1E242B"/>
+                </a:solidFill>
+                <a:latin typeface="Segoe UI"/>
+              </a:rPr>
+              <a:t>Unfiltered signal recording costs disk — the FSR stream alone adds roughly 166 rows a second</a:t>
+            </a:r>
+          </a:p>
+        </p:txBody>
+      </p:sp>
+      <p:sp>
+        <p:nvSpPr>
+          <p:cNvPr id="5" name="Rectangle 4"/>
           <p:cNvSpPr/>
           <p:nvPr/>
         </p:nvSpPr>
@@ -7963,7 +7614,7 @@
       </p:sp>
       <p:sp>
         <p:nvSpPr>
-          <p:cNvPr id="4" name="TextBox 3"/>
+          <p:cNvPr id="6" name="TextBox 5"/>
           <p:cNvSpPr txBox="1"/>
           <p:nvPr/>
         </p:nvSpPr>
@@ -7990,45 +7641,21 @@
                 </a:solidFill>
                 <a:latin typeface="Segoe UI"/>
               </a:rPr>
-              <a:t>Same hardware, same model, same batch. Only the CPU governor changed.</a:t>
-            </a:r>
-          </a:p>
-        </p:txBody>
-      </p:sp>
-      <p:pic>
-        <p:nvPicPr>
-          <p:cNvPr id="5" name="Picture 4" descr="inference_latency.png"/>
-          <p:cNvPicPr>
-            <a:picLocks noChangeAspect="1"/>
-          </p:cNvPicPr>
-          <p:nvPr/>
-        </p:nvPicPr>
-        <p:blipFill>
-          <a:blip r:embed="rId2"/>
-          <a:stretch>
-            <a:fillRect/>
-          </a:stretch>
-        </p:blipFill>
-        <p:spPr>
-          <a:xfrm>
-            <a:off x="1417038" y="1847088"/>
-            <a:ext cx="9357619" cy="3822192"/>
-          </a:xfrm>
-          <a:prstGeom prst="rect">
-            <a:avLst/>
-          </a:prstGeom>
-        </p:spPr>
-      </p:pic>
-      <p:sp>
-        <p:nvSpPr>
-          <p:cNvPr id="6" name="TextBox 5"/>
+              <a:t>The speed work was not the point. This is what it enabled.</a:t>
+            </a:r>
+          </a:p>
+        </p:txBody>
+      </p:sp>
+      <p:sp>
+        <p:nvSpPr>
+          <p:cNvPr id="7" name="TextBox 6"/>
           <p:cNvSpPr txBox="1"/>
           <p:nvPr/>
         </p:nvSpPr>
         <p:spPr>
           <a:xfrm>
-            <a:off x="658368" y="5797296"/>
-            <a:ext cx="10874959" cy="502920"/>
+            <a:off x="658368" y="2103120"/>
+            <a:ext cx="5186019" cy="347472"/>
           </a:xfrm>
           <a:prstGeom prst="rect">
             <a:avLst/>
@@ -8036,34 +7663,33 @@
           <a:noFill/>
         </p:spPr>
         <p:txBody>
-          <a:bodyPr wrap="square">
+          <a:bodyPr wrap="none">
             <a:spAutoFit/>
           </a:bodyPr>
           <a:lstStyle/>
           <a:p>
-            <a:pPr algn="ctr"/>
-            <a:r>
-              <a:rPr sz="1150" b="0" i="1">
-                <a:solidFill>
-                  <a:srgbClr val="6B727B"/>
-                </a:solidFill>
-                <a:latin typeface="Segoe UI"/>
-              </a:rPr>
-              <a:t>powersave held the P-cores near 2700 MHz against a 5000 MHz ceiling. The installer now sets performance, because the default cost more than half the win.</a:t>
-            </a:r>
-          </a:p>
-        </p:txBody>
-      </p:sp>
-      <p:sp>
-        <p:nvSpPr>
-          <p:cNvPr id="7" name="TextBox 6"/>
+            <a:r>
+              <a:rPr sz="1500" b="1" i="0">
+                <a:solidFill>
+                  <a:srgbClr val="6B7F9E"/>
+                </a:solidFill>
+                <a:latin typeface="Segoe UI"/>
+              </a:rPr>
+              <a:t>New abilities</a:t>
+            </a:r>
+          </a:p>
+        </p:txBody>
+      </p:sp>
+      <p:sp>
+        <p:nvSpPr>
+          <p:cNvPr id="8" name="TextBox 7"/>
           <p:cNvSpPr txBox="1"/>
           <p:nvPr/>
         </p:nvSpPr>
         <p:spPr>
           <a:xfrm>
-            <a:off x="658368" y="6382512"/>
-            <a:ext cx="10874959" cy="292608"/>
+            <a:off x="6347307" y="2103120"/>
+            <a:ext cx="5186019" cy="347472"/>
           </a:xfrm>
           <a:prstGeom prst="rect">
             <a:avLst/>
@@ -8077,6 +7703,40 @@
           <a:lstStyle/>
           <a:p>
             <a:r>
+              <a:rPr sz="1500" b="1" i="0">
+                <a:solidFill>
+                  <a:srgbClr val="B3593F"/>
+                </a:solidFill>
+                <a:latin typeface="Segoe UI"/>
+              </a:rPr>
+              <a:t>What it asks of you</a:t>
+            </a:r>
+          </a:p>
+        </p:txBody>
+      </p:sp>
+      <p:sp>
+        <p:nvSpPr>
+          <p:cNvPr id="9" name="TextBox 8"/>
+          <p:cNvSpPr txBox="1"/>
+          <p:nvPr/>
+        </p:nvSpPr>
+        <p:spPr>
+          <a:xfrm>
+            <a:off x="658368" y="6382512"/>
+            <a:ext cx="10874959" cy="292608"/>
+          </a:xfrm>
+          <a:prstGeom prst="rect">
+            <a:avLst/>
+          </a:prstGeom>
+          <a:noFill/>
+        </p:spPr>
+        <p:txBody>
+          <a:bodyPr wrap="none">
+            <a:spAutoFit/>
+          </a:bodyPr>
+          <a:lstStyle/>
+          <a:p>
+            <a:r>
               <a:rPr sz="900" b="0" i="0">
                 <a:solidFill>
                   <a:srgbClr val="6B727B"/>
@@ -8090,7 +7750,7 @@
       </p:sp>
       <p:sp>
         <p:nvSpPr>
-          <p:cNvPr id="8" name="TextBox 7"/>
+          <p:cNvPr id="10" name="TextBox 9"/>
           <p:cNvSpPr txBox="1"/>
           <p:nvPr/>
         </p:nvSpPr>
@@ -8169,99 +7829,14 @@
                 </a:solidFill>
                 <a:latin typeface="Segoe UI"/>
               </a:rPr>
-              <a:t>Running below camera rate is safe by design</a:t>
-            </a:r>
-          </a:p>
-        </p:txBody>
-      </p:sp>
-      <p:sp>
-        <p:nvSpPr>
-          <p:cNvPr id="3" name="Content Placeholder 2"/>
-          <p:cNvSpPr>
-            <a:spLocks noGrp="1"/>
-          </p:cNvSpPr>
-          <p:nvPr>
-            <p:ph idx="1"/>
-          </p:nvPr>
-        </p:nvSpPr>
-        <p:spPr>
-          <a:xfrm>
-            <a:off x="658368" y="2057400"/>
-            <a:ext cx="10874959" cy="4023360"/>
-          </a:xfrm>
-        </p:spPr>
-        <p:txBody>
-          <a:bodyPr wrap="square"/>
-          <a:lstStyle/>
-          <a:p>
-            <a:pPr>
-              <a:spcAft>
-                <a:spcPts val="1300"/>
-              </a:spcAft>
-            </a:pPr>
-            <a:r>
-              <a:rPr sz="1500" b="0" i="0">
-                <a:solidFill>
-                  <a:srgbClr val="1E242B"/>
-                </a:solidFill>
-                <a:latin typeface="Segoe UI"/>
-              </a:rPr>
-              <a:t>Non-blocking backpressure — the 150 fps capture loop hands frames to inference on a separate queue from recording, so a slow pose stage can never stall acquisition or cost a recorded frame. Slowness costs inference work only</a:t>
-            </a:r>
-          </a:p>
-          <a:p>
-            <a:pPr>
-              <a:spcAft>
-                <a:spcPts val="1300"/>
-              </a:spcAft>
-            </a:pPr>
-            <a:r>
-              <a:rPr sz="1500" b="0" i="0">
-                <a:solidFill>
-                  <a:srgbClr val="1E242B"/>
-                </a:solidFill>
-                <a:latin typeface="Segoe UI"/>
-              </a:rPr>
-              <a:t>Freshness drain — inference always takes the newest queued frame and drops stale ones, so latency never grows into a backlog</a:t>
-            </a:r>
-          </a:p>
-          <a:p>
-            <a:pPr>
-              <a:spcAft>
-                <a:spcPts val="1300"/>
-              </a:spcAft>
-            </a:pPr>
-            <a:r>
-              <a:rPr sz="1500" b="0" i="0">
-                <a:solidFill>
-                  <a:srgbClr val="1E242B"/>
-                </a:solidFill>
-                <a:latin typeface="Segoe UI"/>
-              </a:rPr>
-              <a:t>That drain removed up to a full predict period of buffer-sitting: end-to-end went from 17.6 to 13.9 ms, and frames the loop could not hand over fell from 35.2% to 0.7%</a:t>
-            </a:r>
-          </a:p>
-          <a:p>
-            <a:pPr>
-              <a:spcAft>
-                <a:spcPts val="1300"/>
-              </a:spcAft>
-            </a:pPr>
-            <a:r>
-              <a:rPr sz="1500" b="0" i="0">
-                <a:solidFill>
-                  <a:srgbClr val="1E242B"/>
-                </a:solidFill>
-                <a:latin typeface="Segoe UI"/>
-              </a:rPr>
-              <a:t>Both are always on, and neither depends on which backend or model is configured</a:t>
-            </a:r>
-          </a:p>
-        </p:txBody>
-      </p:sp>
-      <p:sp>
-        <p:nvSpPr>
-          <p:cNvPr id="4" name="Rectangle 3"/>
+              <a:t>Everything lands on one timebase</a:t>
+            </a:r>
+          </a:p>
+        </p:txBody>
+      </p:sp>
+      <p:sp>
+        <p:nvSpPr>
+          <p:cNvPr id="3" name="Rectangle 2"/>
           <p:cNvSpPr/>
           <p:nvPr/>
         </p:nvSpPr>
@@ -8305,7 +7880,7 @@
       </p:sp>
       <p:sp>
         <p:nvSpPr>
-          <p:cNvPr id="5" name="TextBox 4"/>
+          <p:cNvPr id="4" name="TextBox 3"/>
           <p:cNvSpPr txBox="1"/>
           <p:nvPr/>
         </p:nvSpPr>
@@ -8332,11 +7907,35 @@
                 </a:solidFill>
                 <a:latin typeface="Segoe UI"/>
               </a:rPr>
-              <a:t>The pose tier is allowed to be slower than the cameras, because it cannot hold them up.</a:t>
-            </a:r>
-          </a:p>
-        </p:txBody>
-      </p:sp>
+              <a:t>Cameras, tones, pellet events and laser output are not separately timestamped and hoped to agree.</a:t>
+            </a:r>
+          </a:p>
+        </p:txBody>
+      </p:sp>
+      <p:pic>
+        <p:nvPicPr>
+          <p:cNvPr id="5" name="Picture 4" descr="synchronization.png"/>
+          <p:cNvPicPr>
+            <a:picLocks noChangeAspect="1"/>
+          </p:cNvPicPr>
+          <p:nvPr/>
+        </p:nvPicPr>
+        <p:blipFill>
+          <a:blip r:embed="rId2"/>
+          <a:stretch>
+            <a:fillRect/>
+          </a:stretch>
+        </p:blipFill>
+        <p:spPr>
+          <a:xfrm>
+            <a:off x="658368" y="1847088"/>
+            <a:ext cx="10874959" cy="3663144"/>
+          </a:xfrm>
+          <a:prstGeom prst="rect">
+            <a:avLst/>
+          </a:prstGeom>
+        </p:spPr>
+      </p:pic>
       <p:sp>
         <p:nvSpPr>
           <p:cNvPr id="6" name="TextBox 5"/>
@@ -8345,8 +7944,8 @@
         </p:nvSpPr>
         <p:spPr>
           <a:xfrm>
-            <a:off x="658368" y="6382512"/>
-            <a:ext cx="10874959" cy="292608"/>
+            <a:off x="658368" y="5638248"/>
+            <a:ext cx="10874959" cy="502920"/>
           </a:xfrm>
           <a:prstGeom prst="rect">
             <a:avLst/>
@@ -8354,6 +7953,41 @@
           <a:noFill/>
         </p:spPr>
         <p:txBody>
+          <a:bodyPr wrap="square">
+            <a:spAutoFit/>
+          </a:bodyPr>
+          <a:lstStyle/>
+          <a:p>
+            <a:pPr algn="ctr"/>
+            <a:r>
+              <a:rPr sz="1150" b="0" i="1">
+                <a:solidFill>
+                  <a:srgbClr val="6B727B"/>
+                </a:solidFill>
+                <a:latin typeface="Segoe UI"/>
+              </a:rPr>
+              <a:t>Camera frame edges are matched to NI-DAQ samples with a signed offset, a resolution, and a confidence — all written into alignment.json.</a:t>
+            </a:r>
+          </a:p>
+        </p:txBody>
+      </p:sp>
+      <p:sp>
+        <p:nvSpPr>
+          <p:cNvPr id="7" name="TextBox 6"/>
+          <p:cNvSpPr txBox="1"/>
+          <p:nvPr/>
+        </p:nvSpPr>
+        <p:spPr>
+          <a:xfrm>
+            <a:off x="658368" y="6382512"/>
+            <a:ext cx="10874959" cy="292608"/>
+          </a:xfrm>
+          <a:prstGeom prst="rect">
+            <a:avLst/>
+          </a:prstGeom>
+          <a:noFill/>
+        </p:spPr>
+        <p:txBody>
           <a:bodyPr wrap="none">
             <a:spAutoFit/>
           </a:bodyPr>
@@ -8373,7 +8007,7 @@
       </p:sp>
       <p:sp>
         <p:nvSpPr>
-          <p:cNvPr id="7" name="TextBox 6"/>
+          <p:cNvPr id="8" name="TextBox 7"/>
           <p:cNvSpPr txBox="1"/>
           <p:nvPr/>
         </p:nvSpPr>

</xml_diff>